<commit_message>
Slides: add six backup slides for Q&A; reframe hypotheses as research questions
Co-authored-by: arena-agent <297053741+arena-agent@users.noreply.github.com>
</commit_message>
<xml_diff>
--- a/reports/slides/fyp2_viva.pptx
+++ b/reports/slides/fyp2_viva.pptx
@@ -18,6 +18,13 @@
     <p:sldId id="266" r:id="rId18"/>
     <p:sldId id="267" r:id="rId19"/>
     <p:sldId id="268" r:id="rId20"/>
+    <p:sldId id="269" r:id="rId21"/>
+    <p:sldId id="270" r:id="rId22"/>
+    <p:sldId id="271" r:id="rId23"/>
+    <p:sldId id="272" r:id="rId24"/>
+    <p:sldId id="273" r:id="rId25"/>
+    <p:sldId id="274" r:id="rId26"/>
+    <p:sldId id="275" r:id="rId27"/>
   </p:sldIdLst>
   <p:sldSz cx="12191695" cy="6858000" type="screen4x3"/>
   <p:notesSz cx="6858000" cy="9144000"/>
@@ -1064,6 +1071,461 @@
 </p:notes>
 </file>
 
+<file path=ppt/notesSlides/notesSlide14.xml><?xml version="1.0" encoding="utf-8"?>
+<p:notes xmlns:a="http://schemas.openxmlformats.org/drawingml/2006/main" xmlns:p="http://schemas.openxmlformats.org/presentationml/2006/main" xmlns:r="http://schemas.openxmlformats.org/officeDocument/2006/relationships">
+  <p:cSld>
+    <p:spTree>
+      <p:nvGrpSpPr>
+        <p:cNvPr id="1" name=""/>
+        <p:cNvGrpSpPr/>
+        <p:nvPr/>
+      </p:nvGrpSpPr>
+      <p:grpSpPr>
+        <a:xfrm>
+          <a:off x="0" y="0"/>
+          <a:ext cx="0" cy="0"/>
+          <a:chOff x="0" y="0"/>
+          <a:chExt cx="0" cy="0"/>
+        </a:xfrm>
+      </p:grpSpPr>
+      <p:sp>
+        <p:nvSpPr>
+          <p:cNvPr id="2" name="Slide Image Placeholder 1"/>
+          <p:cNvSpPr>
+            <a:spLocks noGrp="1"/>
+          </p:cNvSpPr>
+          <p:nvPr>
+            <p:ph type="sldImg" idx="2"/>
+          </p:nvPr>
+        </p:nvSpPr>
+        <p:spPr/>
+      </p:sp>
+      <p:sp>
+        <p:nvSpPr>
+          <p:cNvPr id="3" name="Notes Placeholder 2"/>
+          <p:cNvSpPr>
+            <a:spLocks noGrp="1"/>
+          </p:cNvSpPr>
+          <p:nvPr>
+            <p:ph type="body" idx="3" sz="quarter"/>
+          </p:nvPr>
+        </p:nvSpPr>
+        <p:spPr/>
+        <p:txBody>
+          <a:bodyPr/>
+          <a:lstStyle/>
+          <a:p>
+            <a:r>
+              <a:t>Divider. Do not present. Jump straight to the slide you need.</a:t>
+            </a:r>
+          </a:p>
+        </p:txBody>
+      </p:sp>
+      <p:sp>
+        <p:nvSpPr>
+          <p:cNvPr id="4" name="Slide Number Placeholder 3"/>
+          <p:cNvSpPr>
+            <a:spLocks noGrp="1"/>
+          </p:cNvSpPr>
+          <p:nvPr>
+            <p:ph type="sldNum" idx="5" sz="quarter"/>
+          </p:nvPr>
+        </p:nvSpPr>
+        <p:spPr/>
+      </p:sp>
+    </p:spTree>
+  </p:cSld>
+  <p:clrMapOvr>
+    <a:masterClrMapping/>
+  </p:clrMapOvr>
+</p:notes>
+</file>
+
+<file path=ppt/notesSlides/notesSlide15.xml><?xml version="1.0" encoding="utf-8"?>
+<p:notes xmlns:a="http://schemas.openxmlformats.org/drawingml/2006/main" xmlns:p="http://schemas.openxmlformats.org/presentationml/2006/main" xmlns:r="http://schemas.openxmlformats.org/officeDocument/2006/relationships">
+  <p:cSld>
+    <p:spTree>
+      <p:nvGrpSpPr>
+        <p:cNvPr id="1" name=""/>
+        <p:cNvGrpSpPr/>
+        <p:nvPr/>
+      </p:nvGrpSpPr>
+      <p:grpSpPr>
+        <a:xfrm>
+          <a:off x="0" y="0"/>
+          <a:ext cx="0" cy="0"/>
+          <a:chOff x="0" y="0"/>
+          <a:chExt cx="0" cy="0"/>
+        </a:xfrm>
+      </p:grpSpPr>
+      <p:sp>
+        <p:nvSpPr>
+          <p:cNvPr id="2" name="Slide Image Placeholder 1"/>
+          <p:cNvSpPr>
+            <a:spLocks noGrp="1"/>
+          </p:cNvSpPr>
+          <p:nvPr>
+            <p:ph type="sldImg" idx="2"/>
+          </p:nvPr>
+        </p:nvSpPr>
+        <p:spPr/>
+      </p:sp>
+      <p:sp>
+        <p:nvSpPr>
+          <p:cNvPr id="3" name="Notes Placeholder 2"/>
+          <p:cNvSpPr>
+            <a:spLocks noGrp="1"/>
+          </p:cNvSpPr>
+          <p:nvPr>
+            <p:ph type="body" idx="3" sz="quarter"/>
+          </p:nvPr>
+        </p:nvSpPr>
+        <p:spPr/>
+        <p:txBody>
+          <a:bodyPr/>
+          <a:lstStyle/>
+          <a:p>
+            <a:r>
+              <a:t>Of 9,809 legitimate messages, 90 were wrongly flagged - 0.9%. Of 10,479 phishing messages,</a:t>
+            </a:r>
+          </a:p>
+          <a:p>
+            <a:r>
+              <a:t>80 were missed. Because flagged mail is quarantined rather than deleted, a false positive is</a:t>
+            </a:r>
+          </a:p>
+          <a:p>
+            <a:r>
+              <a:t>recoverable by the user and correctable through the review console.</a:t>
+            </a:r>
+          </a:p>
+        </p:txBody>
+      </p:sp>
+      <p:sp>
+        <p:nvSpPr>
+          <p:cNvPr id="4" name="Slide Number Placeholder 3"/>
+          <p:cNvSpPr>
+            <a:spLocks noGrp="1"/>
+          </p:cNvSpPr>
+          <p:nvPr>
+            <p:ph type="sldNum" idx="5" sz="quarter"/>
+          </p:nvPr>
+        </p:nvSpPr>
+        <p:spPr/>
+      </p:sp>
+    </p:spTree>
+  </p:cSld>
+  <p:clrMapOvr>
+    <a:masterClrMapping/>
+  </p:clrMapOvr>
+</p:notes>
+</file>
+
+<file path=ppt/notesSlides/notesSlide16.xml><?xml version="1.0" encoding="utf-8"?>
+<p:notes xmlns:a="http://schemas.openxmlformats.org/drawingml/2006/main" xmlns:p="http://schemas.openxmlformats.org/presentationml/2006/main" xmlns:r="http://schemas.openxmlformats.org/officeDocument/2006/relationships">
+  <p:cSld>
+    <p:spTree>
+      <p:nvGrpSpPr>
+        <p:cNvPr id="1" name=""/>
+        <p:cNvGrpSpPr/>
+        <p:nvPr/>
+      </p:nvGrpSpPr>
+      <p:grpSpPr>
+        <a:xfrm>
+          <a:off x="0" y="0"/>
+          <a:ext cx="0" cy="0"/>
+          <a:chOff x="0" y="0"/>
+          <a:chExt cx="0" cy="0"/>
+        </a:xfrm>
+      </p:grpSpPr>
+      <p:sp>
+        <p:nvSpPr>
+          <p:cNvPr id="2" name="Slide Image Placeholder 1"/>
+          <p:cNvSpPr>
+            <a:spLocks noGrp="1"/>
+          </p:cNvSpPr>
+          <p:nvPr>
+            <p:ph type="sldImg" idx="2"/>
+          </p:nvPr>
+        </p:nvSpPr>
+        <p:spPr/>
+      </p:sp>
+      <p:sp>
+        <p:nvSpPr>
+          <p:cNvPr id="3" name="Notes Placeholder 2"/>
+          <p:cNvSpPr>
+            <a:spLocks noGrp="1"/>
+          </p:cNvSpPr>
+          <p:nvPr>
+            <p:ph type="body" idx="3" sz="quarter"/>
+          </p:nvPr>
+        </p:nvSpPr>
+        <p:spPr/>
+        <p:txBody>
+          <a:bodyPr/>
+          <a:lstStyle/>
+          <a:p>
+            <a:r>
+              <a:t>Reference table. The deployed configuration is the fourth row.</a:t>
+            </a:r>
+          </a:p>
+        </p:txBody>
+      </p:sp>
+      <p:sp>
+        <p:nvSpPr>
+          <p:cNvPr id="4" name="Slide Number Placeholder 3"/>
+          <p:cNvSpPr>
+            <a:spLocks noGrp="1"/>
+          </p:cNvSpPr>
+          <p:nvPr>
+            <p:ph type="sldNum" idx="5" sz="quarter"/>
+          </p:nvPr>
+        </p:nvSpPr>
+        <p:spPr/>
+      </p:sp>
+    </p:spTree>
+  </p:cSld>
+  <p:clrMapOvr>
+    <a:masterClrMapping/>
+  </p:clrMapOvr>
+</p:notes>
+</file>
+
+<file path=ppt/notesSlides/notesSlide17.xml><?xml version="1.0" encoding="utf-8"?>
+<p:notes xmlns:a="http://schemas.openxmlformats.org/drawingml/2006/main" xmlns:p="http://schemas.openxmlformats.org/presentationml/2006/main" xmlns:r="http://schemas.openxmlformats.org/officeDocument/2006/relationships">
+  <p:cSld>
+    <p:spTree>
+      <p:nvGrpSpPr>
+        <p:cNvPr id="1" name=""/>
+        <p:cNvGrpSpPr/>
+        <p:nvPr/>
+      </p:nvGrpSpPr>
+      <p:grpSpPr>
+        <a:xfrm>
+          <a:off x="0" y="0"/>
+          <a:ext cx="0" cy="0"/>
+          <a:chOff x="0" y="0"/>
+          <a:chExt cx="0" cy="0"/>
+        </a:xfrm>
+      </p:grpSpPr>
+      <p:sp>
+        <p:nvSpPr>
+          <p:cNvPr id="2" name="Slide Image Placeholder 1"/>
+          <p:cNvSpPr>
+            <a:spLocks noGrp="1"/>
+          </p:cNvSpPr>
+          <p:nvPr>
+            <p:ph type="sldImg" idx="2"/>
+          </p:nvPr>
+        </p:nvSpPr>
+        <p:spPr/>
+      </p:sp>
+      <p:sp>
+        <p:nvSpPr>
+          <p:cNvPr id="3" name="Notes Placeholder 2"/>
+          <p:cNvSpPr>
+            <a:spLocks noGrp="1"/>
+          </p:cNvSpPr>
+          <p:nvPr>
+            <p:ph type="body" idx="3" sz="quarter"/>
+          </p:nvPr>
+        </p:nvSpPr>
+        <p:spPr/>
+        <p:txBody>
+          <a:bodyPr/>
+          <a:lstStyle/>
+          <a:p>
+            <a:r>
+              <a:t>These are standardised before fusion so that raw magnitudes - body length can be several</a:t>
+            </a:r>
+          </a:p>
+          <a:p>
+            <a:r>
+              <a:t>thousand while TF-IDF values sit below one - do not dominate the text features.</a:t>
+            </a:r>
+          </a:p>
+        </p:txBody>
+      </p:sp>
+      <p:sp>
+        <p:nvSpPr>
+          <p:cNvPr id="4" name="Slide Number Placeholder 3"/>
+          <p:cNvSpPr>
+            <a:spLocks noGrp="1"/>
+          </p:cNvSpPr>
+          <p:nvPr>
+            <p:ph type="sldNum" idx="5" sz="quarter"/>
+          </p:nvPr>
+        </p:nvSpPr>
+        <p:spPr/>
+      </p:sp>
+    </p:spTree>
+  </p:cSld>
+  <p:clrMapOvr>
+    <a:masterClrMapping/>
+  </p:clrMapOvr>
+</p:notes>
+</file>
+
+<file path=ppt/notesSlides/notesSlide18.xml><?xml version="1.0" encoding="utf-8"?>
+<p:notes xmlns:a="http://schemas.openxmlformats.org/drawingml/2006/main" xmlns:p="http://schemas.openxmlformats.org/presentationml/2006/main" xmlns:r="http://schemas.openxmlformats.org/officeDocument/2006/relationships">
+  <p:cSld>
+    <p:spTree>
+      <p:nvGrpSpPr>
+        <p:cNvPr id="1" name=""/>
+        <p:cNvGrpSpPr/>
+        <p:nvPr/>
+      </p:nvGrpSpPr>
+      <p:grpSpPr>
+        <a:xfrm>
+          <a:off x="0" y="0"/>
+          <a:ext cx="0" cy="0"/>
+          <a:chOff x="0" y="0"/>
+          <a:chExt cx="0" cy="0"/>
+        </a:xfrm>
+      </p:grpSpPr>
+      <p:sp>
+        <p:nvSpPr>
+          <p:cNvPr id="2" name="Slide Image Placeholder 1"/>
+          <p:cNvSpPr>
+            <a:spLocks noGrp="1"/>
+          </p:cNvSpPr>
+          <p:nvPr>
+            <p:ph type="sldImg" idx="2"/>
+          </p:nvPr>
+        </p:nvSpPr>
+        <p:spPr/>
+      </p:sp>
+      <p:sp>
+        <p:nvSpPr>
+          <p:cNvPr id="3" name="Notes Placeholder 2"/>
+          <p:cNvSpPr>
+            <a:spLocks noGrp="1"/>
+          </p:cNvSpPr>
+          <p:nvPr>
+            <p:ph type="body" idx="3" sz="quarter"/>
+          </p:nvPr>
+        </p:nvSpPr>
+        <p:spPr/>
+        <p:txBody>
+          <a:bodyPr/>
+          <a:lstStyle/>
+          <a:p>
+            <a:r>
+              <a:t>Only use this if asked about commercial filters. Lead with the caveat: the test sets differ,</a:t>
+            </a:r>
+          </a:p>
+          <a:p>
+            <a:r>
+              <a:t>so this is context, not a comparison. Opara's study used 63 messages; mine used 4,986.</a:t>
+            </a:r>
+          </a:p>
+        </p:txBody>
+      </p:sp>
+      <p:sp>
+        <p:nvSpPr>
+          <p:cNvPr id="4" name="Slide Number Placeholder 3"/>
+          <p:cNvSpPr>
+            <a:spLocks noGrp="1"/>
+          </p:cNvSpPr>
+          <p:nvPr>
+            <p:ph type="sldNum" idx="5" sz="quarter"/>
+          </p:nvPr>
+        </p:nvSpPr>
+        <p:spPr/>
+      </p:sp>
+    </p:spTree>
+  </p:cSld>
+  <p:clrMapOvr>
+    <a:masterClrMapping/>
+  </p:clrMapOvr>
+</p:notes>
+</file>
+
+<file path=ppt/notesSlides/notesSlide19.xml><?xml version="1.0" encoding="utf-8"?>
+<p:notes xmlns:a="http://schemas.openxmlformats.org/drawingml/2006/main" xmlns:p="http://schemas.openxmlformats.org/presentationml/2006/main" xmlns:r="http://schemas.openxmlformats.org/officeDocument/2006/relationships">
+  <p:cSld>
+    <p:spTree>
+      <p:nvGrpSpPr>
+        <p:cNvPr id="1" name=""/>
+        <p:cNvGrpSpPr/>
+        <p:nvPr/>
+      </p:nvGrpSpPr>
+      <p:grpSpPr>
+        <a:xfrm>
+          <a:off x="0" y="0"/>
+          <a:ext cx="0" cy="0"/>
+          <a:chOff x="0" y="0"/>
+          <a:chExt cx="0" cy="0"/>
+        </a:xfrm>
+      </p:grpSpPr>
+      <p:sp>
+        <p:nvSpPr>
+          <p:cNvPr id="2" name="Slide Image Placeholder 1"/>
+          <p:cNvSpPr>
+            <a:spLocks noGrp="1"/>
+          </p:cNvSpPr>
+          <p:nvPr>
+            <p:ph type="sldImg" idx="2"/>
+          </p:nvPr>
+        </p:nvSpPr>
+        <p:spPr/>
+      </p:sp>
+      <p:sp>
+        <p:nvSpPr>
+          <p:cNvPr id="3" name="Notes Placeholder 2"/>
+          <p:cNvSpPr>
+            <a:spLocks noGrp="1"/>
+          </p:cNvSpPr>
+          <p:nvPr>
+            <p:ph type="body" idx="3" sz="quarter"/>
+          </p:nvPr>
+        </p:nvSpPr>
+        <p:spPr/>
+        <p:txBody>
+          <a:bodyPr/>
+          <a:lstStyle/>
+          <a:p>
+            <a:r>
+              <a:t>If asked about poisoning: be honest. The gate validates against a held-out split of the</a:t>
+            </a:r>
+          </a:p>
+          <a:p>
+            <a:r>
+              <a:t>historical corpus, so it catches general degradation but not corrections that are internally</a:t>
+            </a:r>
+          </a:p>
+          <a:p>
+            <a:r>
+              <a:t>consistent and mislabelled. That is why the reviewer checkpoint matters, and why every</a:t>
+            </a:r>
+          </a:p>
+          <a:p>
+            <a:r>
+              <a:t>replaced model is archived - I tested recovery and restored the exact previous version.</a:t>
+            </a:r>
+          </a:p>
+        </p:txBody>
+      </p:sp>
+      <p:sp>
+        <p:nvSpPr>
+          <p:cNvPr id="4" name="Slide Number Placeholder 3"/>
+          <p:cNvSpPr>
+            <a:spLocks noGrp="1"/>
+          </p:cNvSpPr>
+          <p:nvPr>
+            <p:ph type="sldNum" idx="5" sz="quarter"/>
+          </p:nvPr>
+        </p:nvSpPr>
+        <p:spPr/>
+      </p:sp>
+    </p:spTree>
+  </p:cSld>
+  <p:clrMapOvr>
+    <a:masterClrMapping/>
+  </p:clrMapOvr>
+</p:notes>
+</file>
+
 <file path=ppt/notesSlides/notesSlide2.xml><?xml version="1.0" encoding="utf-8"?>
 <p:notes xmlns:a="http://schemas.openxmlformats.org/drawingml/2006/main" xmlns:p="http://schemas.openxmlformats.org/presentationml/2006/main" xmlns:r="http://schemas.openxmlformats.org/officeDocument/2006/relationships">
   <p:cSld>
@@ -1120,6 +1582,81 @@
           <a:p>
             <a:r>
               <a:t>[30 seconds. The brief asks for an outline - this slide satisfies that.]</a:t>
+            </a:r>
+          </a:p>
+        </p:txBody>
+      </p:sp>
+      <p:sp>
+        <p:nvSpPr>
+          <p:cNvPr id="4" name="Slide Number Placeholder 3"/>
+          <p:cNvSpPr>
+            <a:spLocks noGrp="1"/>
+          </p:cNvSpPr>
+          <p:nvPr>
+            <p:ph type="sldNum" idx="5" sz="quarter"/>
+          </p:nvPr>
+        </p:nvSpPr>
+        <p:spPr/>
+      </p:sp>
+    </p:spTree>
+  </p:cSld>
+  <p:clrMapOvr>
+    <a:masterClrMapping/>
+  </p:clrMapOvr>
+</p:notes>
+</file>
+
+<file path=ppt/notesSlides/notesSlide20.xml><?xml version="1.0" encoding="utf-8"?>
+<p:notes xmlns:a="http://schemas.openxmlformats.org/drawingml/2006/main" xmlns:p="http://schemas.openxmlformats.org/presentationml/2006/main" xmlns:r="http://schemas.openxmlformats.org/officeDocument/2006/relationships">
+  <p:cSld>
+    <p:spTree>
+      <p:nvGrpSpPr>
+        <p:cNvPr id="1" name=""/>
+        <p:cNvGrpSpPr/>
+        <p:nvPr/>
+      </p:nvGrpSpPr>
+      <p:grpSpPr>
+        <a:xfrm>
+          <a:off x="0" y="0"/>
+          <a:ext cx="0" cy="0"/>
+          <a:chOff x="0" y="0"/>
+          <a:chExt cx="0" cy="0"/>
+        </a:xfrm>
+      </p:grpSpPr>
+      <p:sp>
+        <p:nvSpPr>
+          <p:cNvPr id="2" name="Slide Image Placeholder 1"/>
+          <p:cNvSpPr>
+            <a:spLocks noGrp="1"/>
+          </p:cNvSpPr>
+          <p:nvPr>
+            <p:ph type="sldImg" idx="2"/>
+          </p:nvPr>
+        </p:nvSpPr>
+        <p:spPr/>
+      </p:sp>
+      <p:sp>
+        <p:nvSpPr>
+          <p:cNvPr id="3" name="Notes Placeholder 2"/>
+          <p:cNvSpPr>
+            <a:spLocks noGrp="1"/>
+          </p:cNvSpPr>
+          <p:nvPr>
+            <p:ph type="body" idx="3" sz="quarter"/>
+          </p:nvPr>
+        </p:nvSpPr>
+        <p:spPr/>
+        <p:txBody>
+          <a:bodyPr/>
+          <a:lstStyle/>
+          <a:p>
+            <a:r>
+              <a:t>Use this if asked what went wrong during implementation. The metadata scaling issue is the most</a:t>
+            </a:r>
+          </a:p>
+          <a:p>
+            <a:r>
+              <a:t>interesting one - short phishing messages were misclassified until the scaler was added.</a:t>
             </a:r>
           </a:p>
         </p:txBody>
@@ -1471,44 +2008,39 @@
           <a:lstStyle/>
           <a:p>
             <a:r>
-              <a:t>The project tests two hypotheses.</a:t>
+              <a:t>Two research questions followed from the gap analysis.</a:t>
             </a:r>
           </a:p>
           <a:p/>
           <a:p>
             <a:r>
-              <a:t>The first is that combining textual content with structural metadata gives more robust</a:t>
-            </a:r>
-          </a:p>
-          <a:p>
-            <a:r>
-              <a:t>detection than content alone. I tested this directly by training every classifier twice - once</a:t>
-            </a:r>
-          </a:p>
-          <a:p>
-            <a:r>
-              <a:t>on content only, once on the fused feature set - under identical conditions.</a:t>
+              <a:t>The first: does combining textual content with structural metadata improve detection over</a:t>
+            </a:r>
+          </a:p>
+          <a:p>
+            <a:r>
+              <a:t>content alone? I answered this by training every classifier twice - once on content only, once</a:t>
+            </a:r>
+          </a:p>
+          <a:p>
+            <a:r>
+              <a:t>on the fused feature set - under identical conditions.</a:t>
             </a:r>
           </a:p>
           <a:p/>
           <a:p>
             <a:r>
-              <a:t>The second is that reviewed, validation-gated retraining improves detection of represented</a:t>
-            </a:r>
-          </a:p>
-          <a:p>
-            <a:r>
-              <a:t>modern threats while maintaining performance on the main corpus. I tested this with a</a:t>
-            </a:r>
-          </a:p>
-          <a:p>
-            <a:r>
-              <a:t>before-and-after experiment on a held-out modern-threat set, checking main-corpus accuracy</a:t>
-            </a:r>
-          </a:p>
-          <a:p>
-            <a:r>
-              <a:t>was not degraded.</a:t>
+              <a:t>The second: can reviewed, validation-gated retraining improve detection of represented modern</a:t>
+            </a:r>
+          </a:p>
+          <a:p>
+            <a:r>
+              <a:t>threats while maintaining main-corpus performance? I answered this with a before-and-after</a:t>
+            </a:r>
+          </a:p>
+          <a:p>
+            <a:r>
+              <a:t>experiment on a held-out modern-threat set, checking that main-corpus accuracy was not degraded.</a:t>
             </a:r>
           </a:p>
           <a:p/>
@@ -1519,7 +2051,12 @@
           </a:p>
           <a:p>
             <a:r>
-              <a:t>[1 minute. This slide connects your problem analysis directly to your experiments.]</a:t>
+              <a:t>[1 minute. NOTE: the report frames these as the research gap in Section 1.1 and answers them in</a:t>
+            </a:r>
+          </a:p>
+          <a:p>
+            <a:r>
+              <a:t>6.2.2 and 6.2.4 - it does not use the word "hypothesis". If asked, say exactly that.]</a:t>
             </a:r>
           </a:p>
         </p:txBody>
@@ -7335,7 +7872,7 @@
 </p:sld>
 </file>
 
-<file path=ppt/slides/slide2.xml><?xml version="1.0" encoding="utf-8"?>
+<file path=ppt/slides/slide14.xml><?xml version="1.0" encoding="utf-8"?>
 <p:sld xmlns:a="http://schemas.openxmlformats.org/drawingml/2006/main" xmlns:p="http://schemas.openxmlformats.org/presentationml/2006/main" xmlns:r="http://schemas.openxmlformats.org/officeDocument/2006/relationships">
   <p:cSld>
     <p:spTree>
@@ -7423,6 +7960,2851 @@
                 </a:solidFill>
                 <a:latin typeface="Calibri"/>
               </a:rPr>
+              <a:t>Backup Slides</a:t>
+            </a:r>
+          </a:p>
+          <a:p>
+            <a:pPr>
+              <a:spcAft>
+                <a:spcPts val="0"/>
+              </a:spcAft>
+            </a:pPr>
+            <a:r>
+              <a:rPr sz="1300" b="0">
+                <a:solidFill>
+                  <a:srgbClr val="C7DAF2"/>
+                </a:solidFill>
+                <a:latin typeface="Calibri"/>
+              </a:rPr>
+              <a:t>Not presented — reference material for questions</a:t>
+            </a:r>
+          </a:p>
+        </p:txBody>
+      </p:sp>
+      <p:sp>
+        <p:nvSpPr>
+          <p:cNvPr id="4" name="TextBox 3"/>
+          <p:cNvSpPr txBox="1"/>
+          <p:nvPr/>
+        </p:nvSpPr>
+        <p:spPr>
+          <a:xfrm>
+            <a:off x="1188720" y="1737360"/>
+            <a:ext cx="9601200" cy="4114800"/>
+          </a:xfrm>
+          <a:prstGeom prst="rect">
+            <a:avLst/>
+          </a:prstGeom>
+          <a:noFill/>
+        </p:spPr>
+        <p:txBody>
+          <a:bodyPr wrap="square">
+            <a:spAutoFit/>
+          </a:bodyPr>
+          <a:lstStyle/>
+          <a:p>
+            <a:pPr>
+              <a:spcAft>
+                <a:spcPts val="1400"/>
+              </a:spcAft>
+            </a:pPr>
+            <a:r>
+              <a:rPr sz="2000">
+                <a:solidFill>
+                  <a:srgbClr val="1F2A37"/>
+                </a:solidFill>
+                <a:latin typeface="Calibri"/>
+              </a:rPr>
+              <a:t>•  B1  Confusion matrix and error breakdown</a:t>
+            </a:r>
+          </a:p>
+          <a:p>
+            <a:pPr>
+              <a:spcAft>
+                <a:spcPts val="1400"/>
+              </a:spcAft>
+            </a:pPr>
+            <a:r>
+              <a:rPr sz="2000">
+                <a:solidFill>
+                  <a:srgbClr val="1F2A37"/>
+                </a:solidFill>
+                <a:latin typeface="Calibri"/>
+              </a:rPr>
+              <a:t>•  B2  Full classifier comparison (all five configurations)</a:t>
+            </a:r>
+          </a:p>
+          <a:p>
+            <a:pPr>
+              <a:spcAft>
+                <a:spcPts val="1400"/>
+              </a:spcAft>
+            </a:pPr>
+            <a:r>
+              <a:rPr sz="2000">
+                <a:solidFill>
+                  <a:srgbClr val="1F2A37"/>
+                </a:solidFill>
+                <a:latin typeface="Calibri"/>
+              </a:rPr>
+              <a:t>•  B3  Structural metadata signals</a:t>
+            </a:r>
+          </a:p>
+          <a:p>
+            <a:pPr>
+              <a:spcAft>
+                <a:spcPts val="1400"/>
+              </a:spcAft>
+            </a:pPr>
+            <a:r>
+              <a:rPr sz="2000">
+                <a:solidFill>
+                  <a:srgbClr val="1F2A37"/>
+                </a:solidFill>
+                <a:latin typeface="Calibri"/>
+              </a:rPr>
+              <a:t>•  B4  Commercial-filter context</a:t>
+            </a:r>
+          </a:p>
+          <a:p>
+            <a:pPr>
+              <a:spcAft>
+                <a:spcPts val="1400"/>
+              </a:spcAft>
+            </a:pPr>
+            <a:r>
+              <a:rPr sz="2000">
+                <a:solidFill>
+                  <a:srgbClr val="1F2A37"/>
+                </a:solidFill>
+                <a:latin typeface="Calibri"/>
+              </a:rPr>
+              <a:t>•  B5  Validation gate and its known limit</a:t>
+            </a:r>
+          </a:p>
+          <a:p>
+            <a:pPr>
+              <a:spcAft>
+                <a:spcPts val="1400"/>
+              </a:spcAft>
+            </a:pPr>
+            <a:r>
+              <a:rPr sz="2000">
+                <a:solidFill>
+                  <a:srgbClr val="1F2A37"/>
+                </a:solidFill>
+                <a:latin typeface="Calibri"/>
+              </a:rPr>
+              <a:t>•  B6  Implementation issues encountered</a:t>
+            </a:r>
+          </a:p>
+        </p:txBody>
+      </p:sp>
+    </p:spTree>
+  </p:cSld>
+  <p:clrMapOvr>
+    <a:masterClrMapping/>
+  </p:clrMapOvr>
+</p:sld>
+</file>
+
+<file path=ppt/slides/slide15.xml><?xml version="1.0" encoding="utf-8"?>
+<p:sld xmlns:a="http://schemas.openxmlformats.org/drawingml/2006/main" xmlns:p="http://schemas.openxmlformats.org/presentationml/2006/main" xmlns:r="http://schemas.openxmlformats.org/officeDocument/2006/relationships">
+  <p:cSld>
+    <p:spTree>
+      <p:nvGrpSpPr>
+        <p:cNvPr id="1" name=""/>
+        <p:cNvGrpSpPr/>
+        <p:nvPr/>
+      </p:nvGrpSpPr>
+      <p:grpSpPr/>
+      <p:sp>
+        <p:nvSpPr>
+          <p:cNvPr id="2" name="Rectangle 1"/>
+          <p:cNvSpPr/>
+          <p:nvPr/>
+        </p:nvSpPr>
+        <p:spPr>
+          <a:xfrm>
+            <a:off x="0" y="0"/>
+            <a:ext cx="12191695" cy="960120"/>
+          </a:xfrm>
+          <a:prstGeom prst="rect">
+            <a:avLst/>
+          </a:prstGeom>
+          <a:solidFill>
+            <a:srgbClr val="0B2B5B"/>
+          </a:solidFill>
+          <a:ln>
+            <a:noFill/>
+          </a:ln>
+          <a:effectLst/>
+        </p:spPr>
+        <p:style>
+          <a:lnRef idx="1">
+            <a:schemeClr val="accent1"/>
+          </a:lnRef>
+          <a:fillRef idx="3">
+            <a:schemeClr val="accent1"/>
+          </a:fillRef>
+          <a:effectRef idx="2">
+            <a:schemeClr val="accent1"/>
+          </a:effectRef>
+          <a:fontRef idx="minor">
+            <a:schemeClr val="lt1"/>
+          </a:fontRef>
+        </p:style>
+        <p:txBody>
+          <a:bodyPr rtlCol="0" anchor="ctr"/>
+          <a:lstStyle/>
+          <a:p>
+            <a:pPr algn="ctr"/>
+          </a:p>
+        </p:txBody>
+      </p:sp>
+      <p:sp>
+        <p:nvSpPr>
+          <p:cNvPr id="3" name="TextBox 2"/>
+          <p:cNvSpPr txBox="1"/>
+          <p:nvPr/>
+        </p:nvSpPr>
+        <p:spPr>
+          <a:xfrm>
+            <a:off x="502920" y="128016"/>
+            <a:ext cx="11155680" cy="731520"/>
+          </a:xfrm>
+          <a:prstGeom prst="rect">
+            <a:avLst/>
+          </a:prstGeom>
+          <a:noFill/>
+        </p:spPr>
+        <p:txBody>
+          <a:bodyPr wrap="square">
+            <a:spAutoFit/>
+          </a:bodyPr>
+          <a:lstStyle/>
+          <a:p>
+            <a:pPr>
+              <a:spcAft>
+                <a:spcPts val="0"/>
+              </a:spcAft>
+            </a:pPr>
+            <a:r>
+              <a:rPr sz="3000" b="1">
+                <a:solidFill>
+                  <a:srgbClr val="FFFFFF"/>
+                </a:solidFill>
+                <a:latin typeface="Calibri"/>
+              </a:rPr>
+              <a:t>B1  Confusion Matrix</a:t>
+            </a:r>
+          </a:p>
+          <a:p>
+            <a:pPr>
+              <a:spcAft>
+                <a:spcPts val="0"/>
+              </a:spcAft>
+            </a:pPr>
+            <a:r>
+              <a:rPr sz="1300" b="0">
+                <a:solidFill>
+                  <a:srgbClr val="C7DAF2"/>
+                </a:solidFill>
+                <a:latin typeface="Calibri"/>
+              </a:rPr>
+              <a:t>Held-out split, n = 20,288, threshold 0.55</a:t>
+            </a:r>
+          </a:p>
+        </p:txBody>
+      </p:sp>
+      <p:graphicFrame>
+        <p:nvGraphicFramePr>
+          <p:cNvPr id="4" name="Table 3"/>
+          <p:cNvGraphicFramePr>
+            <a:graphicFrameLocks noGrp="1"/>
+          </p:cNvGraphicFramePr>
+          <p:nvPr/>
+        </p:nvGraphicFramePr>
+        <p:xfrm>
+          <a:off x="1280160" y="1554480"/>
+          <a:ext cx="9601200" cy="1152144"/>
+        </p:xfrm>
+        <a:graphic>
+          <a:graphicData uri="http://schemas.openxmlformats.org/drawingml/2006/table">
+            <a:tbl>
+              <a:tblPr firstRow="1" bandRow="1">
+                <a:tableStyleId>{5C22544A-7EE6-4342-B048-85BDC9FD1C3A}</a:tableStyleId>
+              </a:tblPr>
+              <a:tblGrid>
+                <a:gridCol w="3200400"/>
+                <a:gridCol w="3200400"/>
+                <a:gridCol w="3200400"/>
+              </a:tblGrid>
+              <a:tr h="384048">
+                <a:tc>
+                  <a:txBody>
+                    <a:bodyPr/>
+                    <a:lstStyle/>
+                    <a:p>
+                      <a:pPr algn="l"/>
+                    </a:p>
+                  </a:txBody>
+                  <a:tcPr/>
+                </a:tc>
+                <a:tc>
+                  <a:txBody>
+                    <a:bodyPr/>
+                    <a:lstStyle/>
+                    <a:p>
+                      <a:pPr algn="ctr"/>
+                      <a:r>
+                        <a:rPr sz="1500" b="1">
+                          <a:solidFill>
+                            <a:srgbClr val="FFFFFF"/>
+                          </a:solidFill>
+                          <a:latin typeface="Calibri"/>
+                        </a:rPr>
+                        <a:t>Predicted spam</a:t>
+                      </a:r>
+                    </a:p>
+                  </a:txBody>
+                  <a:tcPr/>
+                </a:tc>
+                <a:tc>
+                  <a:txBody>
+                    <a:bodyPr/>
+                    <a:lstStyle/>
+                    <a:p>
+                      <a:pPr algn="ctr"/>
+                      <a:r>
+                        <a:rPr sz="1500" b="1">
+                          <a:solidFill>
+                            <a:srgbClr val="FFFFFF"/>
+                          </a:solidFill>
+                          <a:latin typeface="Calibri"/>
+                        </a:rPr>
+                        <a:t>Predicted legitimate</a:t>
+                      </a:r>
+                    </a:p>
+                  </a:txBody>
+                  <a:tcPr/>
+                </a:tc>
+              </a:tr>
+              <a:tr h="384048">
+                <a:tc>
+                  <a:txBody>
+                    <a:bodyPr/>
+                    <a:lstStyle/>
+                    <a:p>
+                      <a:pPr algn="l"/>
+                      <a:r>
+                        <a:rPr sz="1500" b="0">
+                          <a:solidFill>
+                            <a:srgbClr val="1F2A37"/>
+                          </a:solidFill>
+                          <a:latin typeface="Calibri"/>
+                        </a:rPr>
+                        <a:t>Actually phishing</a:t>
+                      </a:r>
+                    </a:p>
+                  </a:txBody>
+                  <a:tcPr/>
+                </a:tc>
+                <a:tc>
+                  <a:txBody>
+                    <a:bodyPr/>
+                    <a:lstStyle/>
+                    <a:p>
+                      <a:pPr algn="ctr"/>
+                      <a:r>
+                        <a:rPr sz="1500" b="0">
+                          <a:solidFill>
+                            <a:srgbClr val="1F2A37"/>
+                          </a:solidFill>
+                          <a:latin typeface="Calibri"/>
+                        </a:rPr>
+                        <a:t>10,399  (true positive)</a:t>
+                      </a:r>
+                    </a:p>
+                  </a:txBody>
+                  <a:tcPr/>
+                </a:tc>
+                <a:tc>
+                  <a:txBody>
+                    <a:bodyPr/>
+                    <a:lstStyle/>
+                    <a:p>
+                      <a:pPr algn="ctr"/>
+                      <a:r>
+                        <a:rPr sz="1500" b="0">
+                          <a:solidFill>
+                            <a:srgbClr val="1F2A37"/>
+                          </a:solidFill>
+                          <a:latin typeface="Calibri"/>
+                        </a:rPr>
+                        <a:t>80  (false negative)</a:t>
+                      </a:r>
+                    </a:p>
+                  </a:txBody>
+                  <a:tcPr/>
+                </a:tc>
+              </a:tr>
+              <a:tr h="384048">
+                <a:tc>
+                  <a:txBody>
+                    <a:bodyPr/>
+                    <a:lstStyle/>
+                    <a:p>
+                      <a:pPr algn="l"/>
+                      <a:r>
+                        <a:rPr sz="1500" b="0">
+                          <a:solidFill>
+                            <a:srgbClr val="1F2A37"/>
+                          </a:solidFill>
+                          <a:latin typeface="Calibri"/>
+                        </a:rPr>
+                        <a:t>Actually legitimate</a:t>
+                      </a:r>
+                    </a:p>
+                  </a:txBody>
+                  <a:tcPr/>
+                </a:tc>
+                <a:tc>
+                  <a:txBody>
+                    <a:bodyPr/>
+                    <a:lstStyle/>
+                    <a:p>
+                      <a:pPr algn="ctr"/>
+                      <a:r>
+                        <a:rPr sz="1500" b="0">
+                          <a:solidFill>
+                            <a:srgbClr val="1F2A37"/>
+                          </a:solidFill>
+                          <a:latin typeface="Calibri"/>
+                        </a:rPr>
+                        <a:t>90  (false positive)</a:t>
+                      </a:r>
+                    </a:p>
+                  </a:txBody>
+                  <a:tcPr/>
+                </a:tc>
+                <a:tc>
+                  <a:txBody>
+                    <a:bodyPr/>
+                    <a:lstStyle/>
+                    <a:p>
+                      <a:pPr algn="ctr"/>
+                      <a:r>
+                        <a:rPr sz="1500" b="0">
+                          <a:solidFill>
+                            <a:srgbClr val="1F2A37"/>
+                          </a:solidFill>
+                          <a:latin typeface="Calibri"/>
+                        </a:rPr>
+                        <a:t>9,719  (true negative)</a:t>
+                      </a:r>
+                    </a:p>
+                  </a:txBody>
+                  <a:tcPr/>
+                </a:tc>
+              </a:tr>
+            </a:tbl>
+          </a:graphicData>
+        </a:graphic>
+      </p:graphicFrame>
+      <p:sp>
+        <p:nvSpPr>
+          <p:cNvPr id="5" name="TextBox 4"/>
+          <p:cNvSpPr txBox="1"/>
+          <p:nvPr/>
+        </p:nvSpPr>
+        <p:spPr>
+          <a:xfrm>
+            <a:off x="1280160" y="3566160"/>
+            <a:ext cx="9601200" cy="2286000"/>
+          </a:xfrm>
+          <a:prstGeom prst="rect">
+            <a:avLst/>
+          </a:prstGeom>
+          <a:noFill/>
+        </p:spPr>
+        <p:txBody>
+          <a:bodyPr wrap="square">
+            <a:spAutoFit/>
+          </a:bodyPr>
+          <a:lstStyle/>
+          <a:p>
+            <a:pPr>
+              <a:spcAft>
+                <a:spcPts val="1400"/>
+              </a:spcAft>
+            </a:pPr>
+            <a:r>
+              <a:rPr sz="1800">
+                <a:solidFill>
+                  <a:srgbClr val="1F2A37"/>
+                </a:solidFill>
+                <a:latin typeface="Calibri"/>
+              </a:rPr>
+              <a:t>•  False-positive rate = 90 / 9,809 ≈ 0.9%</a:t>
+            </a:r>
+          </a:p>
+          <a:p>
+            <a:pPr>
+              <a:spcAft>
+                <a:spcPts val="1400"/>
+              </a:spcAft>
+            </a:pPr>
+            <a:r>
+              <a:rPr sz="1800">
+                <a:solidFill>
+                  <a:srgbClr val="1F2A37"/>
+                </a:solidFill>
+                <a:latin typeface="Calibri"/>
+              </a:rPr>
+              <a:t>•  False-negative rate = 80 / 10,479 ≈ 0.8%</a:t>
+            </a:r>
+          </a:p>
+          <a:p>
+            <a:pPr>
+              <a:spcAft>
+                <a:spcPts val="1400"/>
+              </a:spcAft>
+            </a:pPr>
+            <a:r>
+              <a:rPr sz="1800">
+                <a:solidFill>
+                  <a:srgbClr val="1F2A37"/>
+                </a:solidFill>
+                <a:latin typeface="Calibri"/>
+              </a:rPr>
+              <a:t>•  Flagged mail is quarantined, so a false positive is recoverable</a:t>
+            </a:r>
+          </a:p>
+        </p:txBody>
+      </p:sp>
+    </p:spTree>
+  </p:cSld>
+  <p:clrMapOvr>
+    <a:masterClrMapping/>
+  </p:clrMapOvr>
+</p:sld>
+</file>
+
+<file path=ppt/slides/slide16.xml><?xml version="1.0" encoding="utf-8"?>
+<p:sld xmlns:a="http://schemas.openxmlformats.org/drawingml/2006/main" xmlns:p="http://schemas.openxmlformats.org/presentationml/2006/main" xmlns:r="http://schemas.openxmlformats.org/officeDocument/2006/relationships">
+  <p:cSld>
+    <p:spTree>
+      <p:nvGrpSpPr>
+        <p:cNvPr id="1" name=""/>
+        <p:cNvGrpSpPr/>
+        <p:nvPr/>
+      </p:nvGrpSpPr>
+      <p:grpSpPr/>
+      <p:sp>
+        <p:nvSpPr>
+          <p:cNvPr id="2" name="Rectangle 1"/>
+          <p:cNvSpPr/>
+          <p:nvPr/>
+        </p:nvSpPr>
+        <p:spPr>
+          <a:xfrm>
+            <a:off x="0" y="0"/>
+            <a:ext cx="12191695" cy="960120"/>
+          </a:xfrm>
+          <a:prstGeom prst="rect">
+            <a:avLst/>
+          </a:prstGeom>
+          <a:solidFill>
+            <a:srgbClr val="0B2B5B"/>
+          </a:solidFill>
+          <a:ln>
+            <a:noFill/>
+          </a:ln>
+          <a:effectLst/>
+        </p:spPr>
+        <p:style>
+          <a:lnRef idx="1">
+            <a:schemeClr val="accent1"/>
+          </a:lnRef>
+          <a:fillRef idx="3">
+            <a:schemeClr val="accent1"/>
+          </a:fillRef>
+          <a:effectRef idx="2">
+            <a:schemeClr val="accent1"/>
+          </a:effectRef>
+          <a:fontRef idx="minor">
+            <a:schemeClr val="lt1"/>
+          </a:fontRef>
+        </p:style>
+        <p:txBody>
+          <a:bodyPr rtlCol="0" anchor="ctr"/>
+          <a:lstStyle/>
+          <a:p>
+            <a:pPr algn="ctr"/>
+          </a:p>
+        </p:txBody>
+      </p:sp>
+      <p:sp>
+        <p:nvSpPr>
+          <p:cNvPr id="3" name="TextBox 2"/>
+          <p:cNvSpPr txBox="1"/>
+          <p:nvPr/>
+        </p:nvSpPr>
+        <p:spPr>
+          <a:xfrm>
+            <a:off x="502920" y="128016"/>
+            <a:ext cx="11155680" cy="731520"/>
+          </a:xfrm>
+          <a:prstGeom prst="rect">
+            <a:avLst/>
+          </a:prstGeom>
+          <a:noFill/>
+        </p:spPr>
+        <p:txBody>
+          <a:bodyPr wrap="square">
+            <a:spAutoFit/>
+          </a:bodyPr>
+          <a:lstStyle/>
+          <a:p>
+            <a:pPr>
+              <a:spcAft>
+                <a:spcPts val="0"/>
+              </a:spcAft>
+            </a:pPr>
+            <a:r>
+              <a:rPr sz="3000" b="1">
+                <a:solidFill>
+                  <a:srgbClr val="FFFFFF"/>
+                </a:solidFill>
+                <a:latin typeface="Calibri"/>
+              </a:rPr>
+              <a:t>B2  Full Classifier Comparison</a:t>
+            </a:r>
+          </a:p>
+          <a:p>
+            <a:pPr>
+              <a:spcAft>
+                <a:spcPts val="0"/>
+              </a:spcAft>
+            </a:pPr>
+            <a:r>
+              <a:rPr sz="1300" b="0">
+                <a:solidFill>
+                  <a:srgbClr val="C7DAF2"/>
+                </a:solidFill>
+                <a:latin typeface="Calibri"/>
+              </a:rPr>
+              <a:t>Same split and preprocessing, default 0.5 threshold</a:t>
+            </a:r>
+          </a:p>
+        </p:txBody>
+      </p:sp>
+      <p:graphicFrame>
+        <p:nvGraphicFramePr>
+          <p:cNvPr id="4" name="Table 3"/>
+          <p:cNvGraphicFramePr>
+            <a:graphicFrameLocks noGrp="1"/>
+          </p:cNvGraphicFramePr>
+          <p:nvPr/>
+        </p:nvGraphicFramePr>
+        <p:xfrm>
+          <a:off x="640080" y="1463040"/>
+          <a:ext cx="10881360" cy="2304288"/>
+        </p:xfrm>
+        <a:graphic>
+          <a:graphicData uri="http://schemas.openxmlformats.org/drawingml/2006/table">
+            <a:tbl>
+              <a:tblPr firstRow="1" bandRow="1">
+                <a:tableStyleId>{5C22544A-7EE6-4342-B048-85BDC9FD1C3A}</a:tableStyleId>
+              </a:tblPr>
+              <a:tblGrid>
+                <a:gridCol w="4023360"/>
+                <a:gridCol w="1371600"/>
+                <a:gridCol w="1371600"/>
+                <a:gridCol w="1371600"/>
+                <a:gridCol w="1371600"/>
+                <a:gridCol w="1371600"/>
+              </a:tblGrid>
+              <a:tr h="384048">
+                <a:tc>
+                  <a:txBody>
+                    <a:bodyPr/>
+                    <a:lstStyle/>
+                    <a:p>
+                      <a:pPr algn="l"/>
+                      <a:r>
+                        <a:rPr sz="1400" b="1">
+                          <a:solidFill>
+                            <a:srgbClr val="FFFFFF"/>
+                          </a:solidFill>
+                          <a:latin typeface="Calibri"/>
+                        </a:rPr>
+                        <a:t>Configuration</a:t>
+                      </a:r>
+                    </a:p>
+                  </a:txBody>
+                  <a:tcPr/>
+                </a:tc>
+                <a:tc>
+                  <a:txBody>
+                    <a:bodyPr/>
+                    <a:lstStyle/>
+                    <a:p>
+                      <a:pPr algn="ctr"/>
+                      <a:r>
+                        <a:rPr sz="1400" b="1">
+                          <a:solidFill>
+                            <a:srgbClr val="FFFFFF"/>
+                          </a:solidFill>
+                          <a:latin typeface="Calibri"/>
+                        </a:rPr>
+                        <a:t>Accuracy</a:t>
+                      </a:r>
+                    </a:p>
+                  </a:txBody>
+                  <a:tcPr/>
+                </a:tc>
+                <a:tc>
+                  <a:txBody>
+                    <a:bodyPr/>
+                    <a:lstStyle/>
+                    <a:p>
+                      <a:pPr algn="ctr"/>
+                      <a:r>
+                        <a:rPr sz="1400" b="1">
+                          <a:solidFill>
+                            <a:srgbClr val="FFFFFF"/>
+                          </a:solidFill>
+                          <a:latin typeface="Calibri"/>
+                        </a:rPr>
+                        <a:t>Precision</a:t>
+                      </a:r>
+                    </a:p>
+                  </a:txBody>
+                  <a:tcPr/>
+                </a:tc>
+                <a:tc>
+                  <a:txBody>
+                    <a:bodyPr/>
+                    <a:lstStyle/>
+                    <a:p>
+                      <a:pPr algn="ctr"/>
+                      <a:r>
+                        <a:rPr sz="1400" b="1">
+                          <a:solidFill>
+                            <a:srgbClr val="FFFFFF"/>
+                          </a:solidFill>
+                          <a:latin typeface="Calibri"/>
+                        </a:rPr>
+                        <a:t>Recall</a:t>
+                      </a:r>
+                    </a:p>
+                  </a:txBody>
+                  <a:tcPr/>
+                </a:tc>
+                <a:tc>
+                  <a:txBody>
+                    <a:bodyPr/>
+                    <a:lstStyle/>
+                    <a:p>
+                      <a:pPr algn="ctr"/>
+                      <a:r>
+                        <a:rPr sz="1400" b="1">
+                          <a:solidFill>
+                            <a:srgbClr val="FFFFFF"/>
+                          </a:solidFill>
+                          <a:latin typeface="Calibri"/>
+                        </a:rPr>
+                        <a:t>F1</a:t>
+                      </a:r>
+                    </a:p>
+                  </a:txBody>
+                  <a:tcPr/>
+                </a:tc>
+                <a:tc>
+                  <a:txBody>
+                    <a:bodyPr/>
+                    <a:lstStyle/>
+                    <a:p>
+                      <a:pPr algn="ctr"/>
+                      <a:r>
+                        <a:rPr sz="1400" b="1">
+                          <a:solidFill>
+                            <a:srgbClr val="FFFFFF"/>
+                          </a:solidFill>
+                          <a:latin typeface="Calibri"/>
+                        </a:rPr>
+                        <a:t>ROC-AUC</a:t>
+                      </a:r>
+                    </a:p>
+                  </a:txBody>
+                  <a:tcPr/>
+                </a:tc>
+              </a:tr>
+              <a:tr h="384048">
+                <a:tc>
+                  <a:txBody>
+                    <a:bodyPr/>
+                    <a:lstStyle/>
+                    <a:p>
+                      <a:pPr algn="l"/>
+                      <a:r>
+                        <a:rPr sz="1400" b="0">
+                          <a:solidFill>
+                            <a:srgbClr val="1F2A37"/>
+                          </a:solidFill>
+                          <a:latin typeface="Calibri"/>
+                        </a:rPr>
+                        <a:t>Naïve Bayes (content only)</a:t>
+                      </a:r>
+                    </a:p>
+                  </a:txBody>
+                  <a:tcPr/>
+                </a:tc>
+                <a:tc>
+                  <a:txBody>
+                    <a:bodyPr/>
+                    <a:lstStyle/>
+                    <a:p>
+                      <a:pPr algn="ctr"/>
+                      <a:r>
+                        <a:rPr sz="1400" b="0">
+                          <a:solidFill>
+                            <a:srgbClr val="1F2A37"/>
+                          </a:solidFill>
+                          <a:latin typeface="Calibri"/>
+                        </a:rPr>
+                        <a:t>0.968</a:t>
+                      </a:r>
+                    </a:p>
+                  </a:txBody>
+                  <a:tcPr/>
+                </a:tc>
+                <a:tc>
+                  <a:txBody>
+                    <a:bodyPr/>
+                    <a:lstStyle/>
+                    <a:p>
+                      <a:pPr algn="ctr"/>
+                      <a:r>
+                        <a:rPr sz="1400" b="0">
+                          <a:solidFill>
+                            <a:srgbClr val="1F2A37"/>
+                          </a:solidFill>
+                          <a:latin typeface="Calibri"/>
+                        </a:rPr>
+                        <a:t>0.988</a:t>
+                      </a:r>
+                    </a:p>
+                  </a:txBody>
+                  <a:tcPr/>
+                </a:tc>
+                <a:tc>
+                  <a:txBody>
+                    <a:bodyPr/>
+                    <a:lstStyle/>
+                    <a:p>
+                      <a:pPr algn="ctr"/>
+                      <a:r>
+                        <a:rPr sz="1400" b="0">
+                          <a:solidFill>
+                            <a:srgbClr val="1F2A37"/>
+                          </a:solidFill>
+                          <a:latin typeface="Calibri"/>
+                        </a:rPr>
+                        <a:t>0.950</a:t>
+                      </a:r>
+                    </a:p>
+                  </a:txBody>
+                  <a:tcPr/>
+                </a:tc>
+                <a:tc>
+                  <a:txBody>
+                    <a:bodyPr/>
+                    <a:lstStyle/>
+                    <a:p>
+                      <a:pPr algn="ctr"/>
+                      <a:r>
+                        <a:rPr sz="1400" b="0">
+                          <a:solidFill>
+                            <a:srgbClr val="1F2A37"/>
+                          </a:solidFill>
+                          <a:latin typeface="Calibri"/>
+                        </a:rPr>
+                        <a:t>0.969</a:t>
+                      </a:r>
+                    </a:p>
+                  </a:txBody>
+                  <a:tcPr/>
+                </a:tc>
+                <a:tc>
+                  <a:txBody>
+                    <a:bodyPr/>
+                    <a:lstStyle/>
+                    <a:p>
+                      <a:pPr algn="ctr"/>
+                      <a:r>
+                        <a:rPr sz="1400" b="0">
+                          <a:solidFill>
+                            <a:srgbClr val="1F2A37"/>
+                          </a:solidFill>
+                          <a:latin typeface="Calibri"/>
+                        </a:rPr>
+                        <a:t>0.997</a:t>
+                      </a:r>
+                    </a:p>
+                  </a:txBody>
+                  <a:tcPr/>
+                </a:tc>
+              </a:tr>
+              <a:tr h="384048">
+                <a:tc>
+                  <a:txBody>
+                    <a:bodyPr/>
+                    <a:lstStyle/>
+                    <a:p>
+                      <a:pPr algn="l"/>
+                      <a:r>
+                        <a:rPr sz="1400" b="0">
+                          <a:solidFill>
+                            <a:srgbClr val="1F2A37"/>
+                          </a:solidFill>
+                          <a:latin typeface="Calibri"/>
+                        </a:rPr>
+                        <a:t>Logistic regression (content only)</a:t>
+                      </a:r>
+                    </a:p>
+                  </a:txBody>
+                  <a:tcPr/>
+                </a:tc>
+                <a:tc>
+                  <a:txBody>
+                    <a:bodyPr/>
+                    <a:lstStyle/>
+                    <a:p>
+                      <a:pPr algn="ctr"/>
+                      <a:r>
+                        <a:rPr sz="1400" b="0">
+                          <a:solidFill>
+                            <a:srgbClr val="1F2A37"/>
+                          </a:solidFill>
+                          <a:latin typeface="Calibri"/>
+                        </a:rPr>
+                        <a:t>0.988</a:t>
+                      </a:r>
+                    </a:p>
+                  </a:txBody>
+                  <a:tcPr/>
+                </a:tc>
+                <a:tc>
+                  <a:txBody>
+                    <a:bodyPr/>
+                    <a:lstStyle/>
+                    <a:p>
+                      <a:pPr algn="ctr"/>
+                      <a:r>
+                        <a:rPr sz="1400" b="0">
+                          <a:solidFill>
+                            <a:srgbClr val="1F2A37"/>
+                          </a:solidFill>
+                          <a:latin typeface="Calibri"/>
+                        </a:rPr>
+                        <a:t>0.987</a:t>
+                      </a:r>
+                    </a:p>
+                  </a:txBody>
+                  <a:tcPr/>
+                </a:tc>
+                <a:tc>
+                  <a:txBody>
+                    <a:bodyPr/>
+                    <a:lstStyle/>
+                    <a:p>
+                      <a:pPr algn="ctr"/>
+                      <a:r>
+                        <a:rPr sz="1400" b="0">
+                          <a:solidFill>
+                            <a:srgbClr val="1F2A37"/>
+                          </a:solidFill>
+                          <a:latin typeface="Calibri"/>
+                        </a:rPr>
+                        <a:t>0.990</a:t>
+                      </a:r>
+                    </a:p>
+                  </a:txBody>
+                  <a:tcPr/>
+                </a:tc>
+                <a:tc>
+                  <a:txBody>
+                    <a:bodyPr/>
+                    <a:lstStyle/>
+                    <a:p>
+                      <a:pPr algn="ctr"/>
+                      <a:r>
+                        <a:rPr sz="1400" b="0">
+                          <a:solidFill>
+                            <a:srgbClr val="1F2A37"/>
+                          </a:solidFill>
+                          <a:latin typeface="Calibri"/>
+                        </a:rPr>
+                        <a:t>0.989</a:t>
+                      </a:r>
+                    </a:p>
+                  </a:txBody>
+                  <a:tcPr/>
+                </a:tc>
+                <a:tc>
+                  <a:txBody>
+                    <a:bodyPr/>
+                    <a:lstStyle/>
+                    <a:p>
+                      <a:pPr algn="ctr"/>
+                      <a:r>
+                        <a:rPr sz="1400" b="0">
+                          <a:solidFill>
+                            <a:srgbClr val="1F2A37"/>
+                          </a:solidFill>
+                          <a:latin typeface="Calibri"/>
+                        </a:rPr>
+                        <a:t>0.999</a:t>
+                      </a:r>
+                    </a:p>
+                  </a:txBody>
+                  <a:tcPr/>
+                </a:tc>
+              </a:tr>
+              <a:tr h="384048">
+                <a:tc>
+                  <a:txBody>
+                    <a:bodyPr/>
+                    <a:lstStyle/>
+                    <a:p>
+                      <a:pPr algn="l"/>
+                      <a:r>
+                        <a:rPr sz="1400" b="0">
+                          <a:solidFill>
+                            <a:srgbClr val="1F2A37"/>
+                          </a:solidFill>
+                          <a:latin typeface="Calibri"/>
+                        </a:rPr>
+                        <a:t>Linear SVM (content only)</a:t>
+                      </a:r>
+                    </a:p>
+                  </a:txBody>
+                  <a:tcPr/>
+                </a:tc>
+                <a:tc>
+                  <a:txBody>
+                    <a:bodyPr/>
+                    <a:lstStyle/>
+                    <a:p>
+                      <a:pPr algn="ctr"/>
+                      <a:r>
+                        <a:rPr sz="1400" b="0">
+                          <a:solidFill>
+                            <a:srgbClr val="1F2A37"/>
+                          </a:solidFill>
+                          <a:latin typeface="Calibri"/>
+                        </a:rPr>
+                        <a:t>0.992</a:t>
+                      </a:r>
+                    </a:p>
+                  </a:txBody>
+                  <a:tcPr/>
+                </a:tc>
+                <a:tc>
+                  <a:txBody>
+                    <a:bodyPr/>
+                    <a:lstStyle/>
+                    <a:p>
+                      <a:pPr algn="ctr"/>
+                      <a:r>
+                        <a:rPr sz="1400" b="0">
+                          <a:solidFill>
+                            <a:srgbClr val="1F2A37"/>
+                          </a:solidFill>
+                          <a:latin typeface="Calibri"/>
+                        </a:rPr>
+                        <a:t>0.990</a:t>
+                      </a:r>
+                    </a:p>
+                  </a:txBody>
+                  <a:tcPr/>
+                </a:tc>
+                <a:tc>
+                  <a:txBody>
+                    <a:bodyPr/>
+                    <a:lstStyle/>
+                    <a:p>
+                      <a:pPr algn="ctr"/>
+                      <a:r>
+                        <a:rPr sz="1400" b="0">
+                          <a:solidFill>
+                            <a:srgbClr val="1F2A37"/>
+                          </a:solidFill>
+                          <a:latin typeface="Calibri"/>
+                        </a:rPr>
+                        <a:t>0.993</a:t>
+                      </a:r>
+                    </a:p>
+                  </a:txBody>
+                  <a:tcPr/>
+                </a:tc>
+                <a:tc>
+                  <a:txBody>
+                    <a:bodyPr/>
+                    <a:lstStyle/>
+                    <a:p>
+                      <a:pPr algn="ctr"/>
+                      <a:r>
+                        <a:rPr sz="1400" b="0">
+                          <a:solidFill>
+                            <a:srgbClr val="1F2A37"/>
+                          </a:solidFill>
+                          <a:latin typeface="Calibri"/>
+                        </a:rPr>
+                        <a:t>0.992</a:t>
+                      </a:r>
+                    </a:p>
+                  </a:txBody>
+                  <a:tcPr/>
+                </a:tc>
+                <a:tc>
+                  <a:txBody>
+                    <a:bodyPr/>
+                    <a:lstStyle/>
+                    <a:p>
+                      <a:pPr algn="ctr"/>
+                      <a:r>
+                        <a:rPr sz="1400" b="0">
+                          <a:solidFill>
+                            <a:srgbClr val="1F2A37"/>
+                          </a:solidFill>
+                          <a:latin typeface="Calibri"/>
+                        </a:rPr>
+                        <a:t>1.000</a:t>
+                      </a:r>
+                    </a:p>
+                  </a:txBody>
+                  <a:tcPr/>
+                </a:tc>
+              </a:tr>
+              <a:tr h="384048">
+                <a:tc>
+                  <a:txBody>
+                    <a:bodyPr/>
+                    <a:lstStyle/>
+                    <a:p>
+                      <a:pPr algn="l"/>
+                      <a:r>
+                        <a:rPr sz="1400" b="0">
+                          <a:solidFill>
+                            <a:srgbClr val="1F2A37"/>
+                          </a:solidFill>
+                          <a:latin typeface="Calibri"/>
+                        </a:rPr>
+                        <a:t>Logistic regression (fusion — deployed)</a:t>
+                      </a:r>
+                    </a:p>
+                  </a:txBody>
+                  <a:tcPr/>
+                </a:tc>
+                <a:tc>
+                  <a:txBody>
+                    <a:bodyPr/>
+                    <a:lstStyle/>
+                    <a:p>
+                      <a:pPr algn="ctr"/>
+                      <a:r>
+                        <a:rPr sz="1400" b="0">
+                          <a:solidFill>
+                            <a:srgbClr val="1F2A37"/>
+                          </a:solidFill>
+                          <a:latin typeface="Calibri"/>
+                        </a:rPr>
+                        <a:t>0.992</a:t>
+                      </a:r>
+                    </a:p>
+                  </a:txBody>
+                  <a:tcPr/>
+                </a:tc>
+                <a:tc>
+                  <a:txBody>
+                    <a:bodyPr/>
+                    <a:lstStyle/>
+                    <a:p>
+                      <a:pPr algn="ctr"/>
+                      <a:r>
+                        <a:rPr sz="1400" b="0">
+                          <a:solidFill>
+                            <a:srgbClr val="1F2A37"/>
+                          </a:solidFill>
+                          <a:latin typeface="Calibri"/>
+                        </a:rPr>
+                        <a:t>0.990</a:t>
+                      </a:r>
+                    </a:p>
+                  </a:txBody>
+                  <a:tcPr/>
+                </a:tc>
+                <a:tc>
+                  <a:txBody>
+                    <a:bodyPr/>
+                    <a:lstStyle/>
+                    <a:p>
+                      <a:pPr algn="ctr"/>
+                      <a:r>
+                        <a:rPr sz="1400" b="0">
+                          <a:solidFill>
+                            <a:srgbClr val="1F2A37"/>
+                          </a:solidFill>
+                          <a:latin typeface="Calibri"/>
+                        </a:rPr>
+                        <a:t>0.994</a:t>
+                      </a:r>
+                    </a:p>
+                  </a:txBody>
+                  <a:tcPr/>
+                </a:tc>
+                <a:tc>
+                  <a:txBody>
+                    <a:bodyPr/>
+                    <a:lstStyle/>
+                    <a:p>
+                      <a:pPr algn="ctr"/>
+                      <a:r>
+                        <a:rPr sz="1400" b="0">
+                          <a:solidFill>
+                            <a:srgbClr val="1F2A37"/>
+                          </a:solidFill>
+                          <a:latin typeface="Calibri"/>
+                        </a:rPr>
+                        <a:t>0.992</a:t>
+                      </a:r>
+                    </a:p>
+                  </a:txBody>
+                  <a:tcPr/>
+                </a:tc>
+                <a:tc>
+                  <a:txBody>
+                    <a:bodyPr/>
+                    <a:lstStyle/>
+                    <a:p>
+                      <a:pPr algn="ctr"/>
+                      <a:r>
+                        <a:rPr sz="1400" b="0">
+                          <a:solidFill>
+                            <a:srgbClr val="1F2A37"/>
+                          </a:solidFill>
+                          <a:latin typeface="Calibri"/>
+                        </a:rPr>
+                        <a:t>1.000</a:t>
+                      </a:r>
+                    </a:p>
+                  </a:txBody>
+                  <a:tcPr/>
+                </a:tc>
+              </a:tr>
+              <a:tr h="384048">
+                <a:tc>
+                  <a:txBody>
+                    <a:bodyPr/>
+                    <a:lstStyle/>
+                    <a:p>
+                      <a:pPr algn="l"/>
+                      <a:r>
+                        <a:rPr sz="1400" b="0">
+                          <a:solidFill>
+                            <a:srgbClr val="1F2A37"/>
+                          </a:solidFill>
+                          <a:latin typeface="Calibri"/>
+                        </a:rPr>
+                        <a:t>Linear SVM (fusion)</a:t>
+                      </a:r>
+                    </a:p>
+                  </a:txBody>
+                  <a:tcPr/>
+                </a:tc>
+                <a:tc>
+                  <a:txBody>
+                    <a:bodyPr/>
+                    <a:lstStyle/>
+                    <a:p>
+                      <a:pPr algn="ctr"/>
+                      <a:r>
+                        <a:rPr sz="1400" b="0">
+                          <a:solidFill>
+                            <a:srgbClr val="1F2A37"/>
+                          </a:solidFill>
+                          <a:latin typeface="Calibri"/>
+                        </a:rPr>
+                        <a:t>0.993</a:t>
+                      </a:r>
+                    </a:p>
+                  </a:txBody>
+                  <a:tcPr/>
+                </a:tc>
+                <a:tc>
+                  <a:txBody>
+                    <a:bodyPr/>
+                    <a:lstStyle/>
+                    <a:p>
+                      <a:pPr algn="ctr"/>
+                      <a:r>
+                        <a:rPr sz="1400" b="0">
+                          <a:solidFill>
+                            <a:srgbClr val="1F2A37"/>
+                          </a:solidFill>
+                          <a:latin typeface="Calibri"/>
+                        </a:rPr>
+                        <a:t>0.992</a:t>
+                      </a:r>
+                    </a:p>
+                  </a:txBody>
+                  <a:tcPr/>
+                </a:tc>
+                <a:tc>
+                  <a:txBody>
+                    <a:bodyPr/>
+                    <a:lstStyle/>
+                    <a:p>
+                      <a:pPr algn="ctr"/>
+                      <a:r>
+                        <a:rPr sz="1400" b="0">
+                          <a:solidFill>
+                            <a:srgbClr val="1F2A37"/>
+                          </a:solidFill>
+                          <a:latin typeface="Calibri"/>
+                        </a:rPr>
+                        <a:t>0.995</a:t>
+                      </a:r>
+                    </a:p>
+                  </a:txBody>
+                  <a:tcPr/>
+                </a:tc>
+                <a:tc>
+                  <a:txBody>
+                    <a:bodyPr/>
+                    <a:lstStyle/>
+                    <a:p>
+                      <a:pPr algn="ctr"/>
+                      <a:r>
+                        <a:rPr sz="1400" b="0">
+                          <a:solidFill>
+                            <a:srgbClr val="1F2A37"/>
+                          </a:solidFill>
+                          <a:latin typeface="Calibri"/>
+                        </a:rPr>
+                        <a:t>0.993</a:t>
+                      </a:r>
+                    </a:p>
+                  </a:txBody>
+                  <a:tcPr/>
+                </a:tc>
+                <a:tc>
+                  <a:txBody>
+                    <a:bodyPr/>
+                    <a:lstStyle/>
+                    <a:p>
+                      <a:pPr algn="ctr"/>
+                      <a:r>
+                        <a:rPr sz="1400" b="0">
+                          <a:solidFill>
+                            <a:srgbClr val="1F2A37"/>
+                          </a:solidFill>
+                          <a:latin typeface="Calibri"/>
+                        </a:rPr>
+                        <a:t>1.000</a:t>
+                      </a:r>
+                    </a:p>
+                  </a:txBody>
+                  <a:tcPr/>
+                </a:tc>
+              </a:tr>
+            </a:tbl>
+          </a:graphicData>
+        </a:graphic>
+      </p:graphicFrame>
+      <p:sp>
+        <p:nvSpPr>
+          <p:cNvPr id="5" name="TextBox 4"/>
+          <p:cNvSpPr txBox="1"/>
+          <p:nvPr/>
+        </p:nvSpPr>
+        <p:spPr>
+          <a:xfrm>
+            <a:off x="822960" y="4480560"/>
+            <a:ext cx="10515600" cy="1463040"/>
+          </a:xfrm>
+          <a:prstGeom prst="rect">
+            <a:avLst/>
+          </a:prstGeom>
+          <a:noFill/>
+        </p:spPr>
+        <p:txBody>
+          <a:bodyPr wrap="square">
+            <a:spAutoFit/>
+          </a:bodyPr>
+          <a:lstStyle/>
+          <a:p>
+            <a:pPr>
+              <a:spcAft>
+                <a:spcPts val="1400"/>
+              </a:spcAft>
+            </a:pPr>
+            <a:r>
+              <a:rPr sz="1600">
+                <a:solidFill>
+                  <a:srgbClr val="1F2A37"/>
+                </a:solidFill>
+                <a:latin typeface="Calibri"/>
+              </a:rPr>
+              <a:t>•  SVM iteration limit raised to 10,000; metrics stable beyond that point</a:t>
+            </a:r>
+          </a:p>
+          <a:p>
+            <a:pPr>
+              <a:spcAft>
+                <a:spcPts val="1400"/>
+              </a:spcAft>
+            </a:pPr>
+            <a:r>
+              <a:rPr sz="1600">
+                <a:solidFill>
+                  <a:srgbClr val="1F2A37"/>
+                </a:solidFill>
+                <a:latin typeface="Calibri"/>
+              </a:rPr>
+              <a:t>•  Deployed model runs at threshold 0.55, not the 0.5 used for this comparison</a:t>
+            </a:r>
+          </a:p>
+        </p:txBody>
+      </p:sp>
+    </p:spTree>
+  </p:cSld>
+  <p:clrMapOvr>
+    <a:masterClrMapping/>
+  </p:clrMapOvr>
+</p:sld>
+</file>
+
+<file path=ppt/slides/slide17.xml><?xml version="1.0" encoding="utf-8"?>
+<p:sld xmlns:a="http://schemas.openxmlformats.org/drawingml/2006/main" xmlns:p="http://schemas.openxmlformats.org/presentationml/2006/main" xmlns:r="http://schemas.openxmlformats.org/officeDocument/2006/relationships">
+  <p:cSld>
+    <p:spTree>
+      <p:nvGrpSpPr>
+        <p:cNvPr id="1" name=""/>
+        <p:cNvGrpSpPr/>
+        <p:nvPr/>
+      </p:nvGrpSpPr>
+      <p:grpSpPr/>
+      <p:sp>
+        <p:nvSpPr>
+          <p:cNvPr id="2" name="Rectangle 1"/>
+          <p:cNvSpPr/>
+          <p:nvPr/>
+        </p:nvSpPr>
+        <p:spPr>
+          <a:xfrm>
+            <a:off x="0" y="0"/>
+            <a:ext cx="12191695" cy="960120"/>
+          </a:xfrm>
+          <a:prstGeom prst="rect">
+            <a:avLst/>
+          </a:prstGeom>
+          <a:solidFill>
+            <a:srgbClr val="0B2B5B"/>
+          </a:solidFill>
+          <a:ln>
+            <a:noFill/>
+          </a:ln>
+          <a:effectLst/>
+        </p:spPr>
+        <p:style>
+          <a:lnRef idx="1">
+            <a:schemeClr val="accent1"/>
+          </a:lnRef>
+          <a:fillRef idx="3">
+            <a:schemeClr val="accent1"/>
+          </a:fillRef>
+          <a:effectRef idx="2">
+            <a:schemeClr val="accent1"/>
+          </a:effectRef>
+          <a:fontRef idx="minor">
+            <a:schemeClr val="lt1"/>
+          </a:fontRef>
+        </p:style>
+        <p:txBody>
+          <a:bodyPr rtlCol="0" anchor="ctr"/>
+          <a:lstStyle/>
+          <a:p>
+            <a:pPr algn="ctr"/>
+          </a:p>
+        </p:txBody>
+      </p:sp>
+      <p:sp>
+        <p:nvSpPr>
+          <p:cNvPr id="3" name="TextBox 2"/>
+          <p:cNvSpPr txBox="1"/>
+          <p:nvPr/>
+        </p:nvSpPr>
+        <p:spPr>
+          <a:xfrm>
+            <a:off x="502920" y="128016"/>
+            <a:ext cx="11155680" cy="731520"/>
+          </a:xfrm>
+          <a:prstGeom prst="rect">
+            <a:avLst/>
+          </a:prstGeom>
+          <a:noFill/>
+        </p:spPr>
+        <p:txBody>
+          <a:bodyPr wrap="square">
+            <a:spAutoFit/>
+          </a:bodyPr>
+          <a:lstStyle/>
+          <a:p>
+            <a:pPr>
+              <a:spcAft>
+                <a:spcPts val="0"/>
+              </a:spcAft>
+            </a:pPr>
+            <a:r>
+              <a:rPr sz="3000" b="1">
+                <a:solidFill>
+                  <a:srgbClr val="FFFFFF"/>
+                </a:solidFill>
+                <a:latin typeface="Calibri"/>
+              </a:rPr>
+              <a:t>B3  Structural Metadata Signals</a:t>
+            </a:r>
+          </a:p>
+        </p:txBody>
+      </p:sp>
+      <p:graphicFrame>
+        <p:nvGraphicFramePr>
+          <p:cNvPr id="4" name="Table 3"/>
+          <p:cNvGraphicFramePr>
+            <a:graphicFrameLocks noGrp="1"/>
+          </p:cNvGraphicFramePr>
+          <p:nvPr/>
+        </p:nvGraphicFramePr>
+        <p:xfrm>
+          <a:off x="822960" y="1417320"/>
+          <a:ext cx="10515600" cy="3840480"/>
+        </p:xfrm>
+        <a:graphic>
+          <a:graphicData uri="http://schemas.openxmlformats.org/drawingml/2006/table">
+            <a:tbl>
+              <a:tblPr firstRow="1" bandRow="1">
+                <a:tableStyleId>{5C22544A-7EE6-4342-B048-85BDC9FD1C3A}</a:tableStyleId>
+              </a:tblPr>
+              <a:tblGrid>
+                <a:gridCol w="4572000"/>
+                <a:gridCol w="5943600"/>
+              </a:tblGrid>
+              <a:tr h="384048">
+                <a:tc>
+                  <a:txBody>
+                    <a:bodyPr/>
+                    <a:lstStyle/>
+                    <a:p>
+                      <a:pPr algn="l"/>
+                      <a:r>
+                        <a:rPr sz="1400" b="1">
+                          <a:solidFill>
+                            <a:srgbClr val="FFFFFF"/>
+                          </a:solidFill>
+                          <a:latin typeface="Calibri"/>
+                        </a:rPr>
+                        <a:t>Signal</a:t>
+                      </a:r>
+                    </a:p>
+                  </a:txBody>
+                  <a:tcPr/>
+                </a:tc>
+                <a:tc>
+                  <a:txBody>
+                    <a:bodyPr/>
+                    <a:lstStyle/>
+                    <a:p>
+                      <a:pPr algn="ctr"/>
+                      <a:r>
+                        <a:rPr sz="1400" b="1">
+                          <a:solidFill>
+                            <a:srgbClr val="FFFFFF"/>
+                          </a:solidFill>
+                          <a:latin typeface="Calibri"/>
+                        </a:rPr>
+                        <a:t>What it captures</a:t>
+                      </a:r>
+                    </a:p>
+                  </a:txBody>
+                  <a:tcPr/>
+                </a:tc>
+              </a:tr>
+              <a:tr h="384048">
+                <a:tc>
+                  <a:txBody>
+                    <a:bodyPr/>
+                    <a:lstStyle/>
+                    <a:p>
+                      <a:pPr algn="l"/>
+                      <a:r>
+                        <a:rPr sz="1400" b="0">
+                          <a:solidFill>
+                            <a:srgbClr val="1F2A37"/>
+                          </a:solidFill>
+                          <a:latin typeface="Calibri"/>
+                        </a:rPr>
+                        <a:t>Subject length / body length</a:t>
+                      </a:r>
+                    </a:p>
+                  </a:txBody>
+                  <a:tcPr/>
+                </a:tc>
+                <a:tc>
+                  <a:txBody>
+                    <a:bodyPr/>
+                    <a:lstStyle/>
+                    <a:p>
+                      <a:pPr algn="ctr"/>
+                      <a:r>
+                        <a:rPr sz="1400" b="0">
+                          <a:solidFill>
+                            <a:srgbClr val="1F2A37"/>
+                          </a:solidFill>
+                          <a:latin typeface="Calibri"/>
+                        </a:rPr>
+                        <a:t>Unusually short or long messages</a:t>
+                      </a:r>
+                    </a:p>
+                  </a:txBody>
+                  <a:tcPr/>
+                </a:tc>
+              </a:tr>
+              <a:tr h="384048">
+                <a:tc>
+                  <a:txBody>
+                    <a:bodyPr/>
+                    <a:lstStyle/>
+                    <a:p>
+                      <a:pPr algn="l"/>
+                      <a:r>
+                        <a:rPr sz="1400" b="0">
+                          <a:solidFill>
+                            <a:srgbClr val="1F2A37"/>
+                          </a:solidFill>
+                          <a:latin typeface="Calibri"/>
+                        </a:rPr>
+                        <a:t>URL count / distinct link domains</a:t>
+                      </a:r>
+                    </a:p>
+                  </a:txBody>
+                  <a:tcPr/>
+                </a:tc>
+                <a:tc>
+                  <a:txBody>
+                    <a:bodyPr/>
+                    <a:lstStyle/>
+                    <a:p>
+                      <a:pPr algn="ctr"/>
+                      <a:r>
+                        <a:rPr sz="1400" b="0">
+                          <a:solidFill>
+                            <a:srgbClr val="1F2A37"/>
+                          </a:solidFill>
+                          <a:latin typeface="Calibri"/>
+                        </a:rPr>
+                        <a:t>Bulk campaigns and link-heavy mail</a:t>
+                      </a:r>
+                    </a:p>
+                  </a:txBody>
+                  <a:tcPr/>
+                </a:tc>
+              </a:tr>
+              <a:tr h="384048">
+                <a:tc>
+                  <a:txBody>
+                    <a:bodyPr/>
+                    <a:lstStyle/>
+                    <a:p>
+                      <a:pPr algn="l"/>
+                      <a:r>
+                        <a:rPr sz="1400" b="0">
+                          <a:solidFill>
+                            <a:srgbClr val="1F2A37"/>
+                          </a:solidFill>
+                          <a:latin typeface="Calibri"/>
+                        </a:rPr>
+                        <a:t>Attachment count</a:t>
+                      </a:r>
+                    </a:p>
+                  </a:txBody>
+                  <a:tcPr/>
+                </a:tc>
+                <a:tc>
+                  <a:txBody>
+                    <a:bodyPr/>
+                    <a:lstStyle/>
+                    <a:p>
+                      <a:pPr algn="ctr"/>
+                      <a:r>
+                        <a:rPr sz="1400" b="0">
+                          <a:solidFill>
+                            <a:srgbClr val="1F2A37"/>
+                          </a:solidFill>
+                          <a:latin typeface="Calibri"/>
+                        </a:rPr>
+                        <a:t>Payload delivery</a:t>
+                      </a:r>
+                    </a:p>
+                  </a:txBody>
+                  <a:tcPr/>
+                </a:tc>
+              </a:tr>
+              <a:tr h="384048">
+                <a:tc>
+                  <a:txBody>
+                    <a:bodyPr/>
+                    <a:lstStyle/>
+                    <a:p>
+                      <a:pPr algn="l"/>
+                      <a:r>
+                        <a:rPr sz="1400" b="0">
+                          <a:solidFill>
+                            <a:srgbClr val="1F2A37"/>
+                          </a:solidFill>
+                          <a:latin typeface="Calibri"/>
+                        </a:rPr>
+                        <a:t>Sender has domain</a:t>
+                      </a:r>
+                    </a:p>
+                  </a:txBody>
+                  <a:tcPr/>
+                </a:tc>
+                <a:tc>
+                  <a:txBody>
+                    <a:bodyPr/>
+                    <a:lstStyle/>
+                    <a:p>
+                      <a:pPr algn="ctr"/>
+                      <a:r>
+                        <a:rPr sz="1400" b="0">
+                          <a:solidFill>
+                            <a:srgbClr val="1F2A37"/>
+                          </a:solidFill>
+                          <a:latin typeface="Calibri"/>
+                        </a:rPr>
+                        <a:t>Malformed or missing sender address</a:t>
+                      </a:r>
+                    </a:p>
+                  </a:txBody>
+                  <a:tcPr/>
+                </a:tc>
+              </a:tr>
+              <a:tr h="384048">
+                <a:tc>
+                  <a:txBody>
+                    <a:bodyPr/>
+                    <a:lstStyle/>
+                    <a:p>
+                      <a:pPr algn="l"/>
+                      <a:r>
+                        <a:rPr sz="1400" b="0">
+                          <a:solidFill>
+                            <a:srgbClr val="1F2A37"/>
+                          </a:solidFill>
+                          <a:latin typeface="Calibri"/>
+                        </a:rPr>
+                        <a:t>Sender–link domain mismatch</a:t>
+                      </a:r>
+                    </a:p>
+                  </a:txBody>
+                  <a:tcPr/>
+                </a:tc>
+                <a:tc>
+                  <a:txBody>
+                    <a:bodyPr/>
+                    <a:lstStyle/>
+                    <a:p>
+                      <a:pPr algn="ctr"/>
+                      <a:r>
+                        <a:rPr sz="1400" b="0">
+                          <a:solidFill>
+                            <a:srgbClr val="1F2A37"/>
+                          </a:solidFill>
+                          <a:latin typeface="Calibri"/>
+                        </a:rPr>
+                        <a:t>Classic phishing indicator</a:t>
+                      </a:r>
+                    </a:p>
+                  </a:txBody>
+                  <a:tcPr/>
+                </a:tc>
+              </a:tr>
+              <a:tr h="384048">
+                <a:tc>
+                  <a:txBody>
+                    <a:bodyPr/>
+                    <a:lstStyle/>
+                    <a:p>
+                      <a:pPr algn="l"/>
+                      <a:r>
+                        <a:rPr sz="1400" b="0">
+                          <a:solidFill>
+                            <a:srgbClr val="1F2A37"/>
+                          </a:solidFill>
+                          <a:latin typeface="Calibri"/>
+                        </a:rPr>
+                        <a:t>Reply-To present</a:t>
+                      </a:r>
+                    </a:p>
+                  </a:txBody>
+                  <a:tcPr/>
+                </a:tc>
+                <a:tc>
+                  <a:txBody>
+                    <a:bodyPr/>
+                    <a:lstStyle/>
+                    <a:p>
+                      <a:pPr algn="ctr"/>
+                      <a:r>
+                        <a:rPr sz="1400" b="0">
+                          <a:solidFill>
+                            <a:srgbClr val="1F2A37"/>
+                          </a:solidFill>
+                          <a:latin typeface="Calibri"/>
+                        </a:rPr>
+                        <a:t>Replies redirected away from the sender</a:t>
+                      </a:r>
+                    </a:p>
+                  </a:txBody>
+                  <a:tcPr/>
+                </a:tc>
+              </a:tr>
+              <a:tr h="384048">
+                <a:tc>
+                  <a:txBody>
+                    <a:bodyPr/>
+                    <a:lstStyle/>
+                    <a:p>
+                      <a:pPr algn="l"/>
+                      <a:r>
+                        <a:rPr sz="1400" b="0">
+                          <a:solidFill>
+                            <a:srgbClr val="1F2A37"/>
+                          </a:solidFill>
+                          <a:latin typeface="Calibri"/>
+                        </a:rPr>
+                        <a:t>SPF result / DKIM present</a:t>
+                      </a:r>
+                    </a:p>
+                  </a:txBody>
+                  <a:tcPr/>
+                </a:tc>
+                <a:tc>
+                  <a:txBody>
+                    <a:bodyPr/>
+                    <a:lstStyle/>
+                    <a:p>
+                      <a:pPr algn="ctr"/>
+                      <a:r>
+                        <a:rPr sz="1400" b="0">
+                          <a:solidFill>
+                            <a:srgbClr val="1F2A37"/>
+                          </a:solidFill>
+                          <a:latin typeface="Calibri"/>
+                        </a:rPr>
+                        <a:t>Authentication indicators</a:t>
+                      </a:r>
+                    </a:p>
+                  </a:txBody>
+                  <a:tcPr/>
+                </a:tc>
+              </a:tr>
+              <a:tr h="384048">
+                <a:tc>
+                  <a:txBody>
+                    <a:bodyPr/>
+                    <a:lstStyle/>
+                    <a:p>
+                      <a:pPr algn="l"/>
+                      <a:r>
+                        <a:rPr sz="1400" b="0">
+                          <a:solidFill>
+                            <a:srgbClr val="1F2A37"/>
+                          </a:solidFill>
+                          <a:latin typeface="Calibri"/>
+                        </a:rPr>
+                        <a:t>Subject capitals ratio / exclamations</a:t>
+                      </a:r>
+                    </a:p>
+                  </a:txBody>
+                  <a:tcPr/>
+                </a:tc>
+                <a:tc>
+                  <a:txBody>
+                    <a:bodyPr/>
+                    <a:lstStyle/>
+                    <a:p>
+                      <a:pPr algn="ctr"/>
+                      <a:r>
+                        <a:rPr sz="1400" b="0">
+                          <a:solidFill>
+                            <a:srgbClr val="1F2A37"/>
+                          </a:solidFill>
+                          <a:latin typeface="Calibri"/>
+                        </a:rPr>
+                        <a:t>Shouting and urgency styling</a:t>
+                      </a:r>
+                    </a:p>
+                  </a:txBody>
+                  <a:tcPr/>
+                </a:tc>
+              </a:tr>
+              <a:tr h="384048">
+                <a:tc>
+                  <a:txBody>
+                    <a:bodyPr/>
+                    <a:lstStyle/>
+                    <a:p>
+                      <a:pPr algn="l"/>
+                      <a:r>
+                        <a:rPr sz="1400" b="0">
+                          <a:solidFill>
+                            <a:srgbClr val="1F2A37"/>
+                          </a:solidFill>
+                          <a:latin typeface="Calibri"/>
+                        </a:rPr>
+                        <a:t>Suspicious-term count</a:t>
+                      </a:r>
+                    </a:p>
+                  </a:txBody>
+                  <a:tcPr/>
+                </a:tc>
+                <a:tc>
+                  <a:txBody>
+                    <a:bodyPr/>
+                    <a:lstStyle/>
+                    <a:p>
+                      <a:pPr algn="ctr"/>
+                      <a:r>
+                        <a:rPr sz="1400" b="0">
+                          <a:solidFill>
+                            <a:srgbClr val="1F2A37"/>
+                          </a:solidFill>
+                          <a:latin typeface="Calibri"/>
+                        </a:rPr>
+                        <a:t>Urgency and verification vocabulary</a:t>
+                      </a:r>
+                    </a:p>
+                  </a:txBody>
+                  <a:tcPr/>
+                </a:tc>
+              </a:tr>
+            </a:tbl>
+          </a:graphicData>
+        </a:graphic>
+      </p:graphicFrame>
+    </p:spTree>
+  </p:cSld>
+  <p:clrMapOvr>
+    <a:masterClrMapping/>
+  </p:clrMapOvr>
+</p:sld>
+</file>
+
+<file path=ppt/slides/slide18.xml><?xml version="1.0" encoding="utf-8"?>
+<p:sld xmlns:a="http://schemas.openxmlformats.org/drawingml/2006/main" xmlns:p="http://schemas.openxmlformats.org/presentationml/2006/main" xmlns:r="http://schemas.openxmlformats.org/officeDocument/2006/relationships">
+  <p:cSld>
+    <p:spTree>
+      <p:nvGrpSpPr>
+        <p:cNvPr id="1" name=""/>
+        <p:cNvGrpSpPr/>
+        <p:nvPr/>
+      </p:nvGrpSpPr>
+      <p:grpSpPr/>
+      <p:sp>
+        <p:nvSpPr>
+          <p:cNvPr id="2" name="Rectangle 1"/>
+          <p:cNvSpPr/>
+          <p:nvPr/>
+        </p:nvSpPr>
+        <p:spPr>
+          <a:xfrm>
+            <a:off x="0" y="0"/>
+            <a:ext cx="12191695" cy="960120"/>
+          </a:xfrm>
+          <a:prstGeom prst="rect">
+            <a:avLst/>
+          </a:prstGeom>
+          <a:solidFill>
+            <a:srgbClr val="0B2B5B"/>
+          </a:solidFill>
+          <a:ln>
+            <a:noFill/>
+          </a:ln>
+          <a:effectLst/>
+        </p:spPr>
+        <p:style>
+          <a:lnRef idx="1">
+            <a:schemeClr val="accent1"/>
+          </a:lnRef>
+          <a:fillRef idx="3">
+            <a:schemeClr val="accent1"/>
+          </a:fillRef>
+          <a:effectRef idx="2">
+            <a:schemeClr val="accent1"/>
+          </a:effectRef>
+          <a:fontRef idx="minor">
+            <a:schemeClr val="lt1"/>
+          </a:fontRef>
+        </p:style>
+        <p:txBody>
+          <a:bodyPr rtlCol="0" anchor="ctr"/>
+          <a:lstStyle/>
+          <a:p>
+            <a:pPr algn="ctr"/>
+          </a:p>
+        </p:txBody>
+      </p:sp>
+      <p:sp>
+        <p:nvSpPr>
+          <p:cNvPr id="3" name="TextBox 2"/>
+          <p:cNvSpPr txBox="1"/>
+          <p:nvPr/>
+        </p:nvSpPr>
+        <p:spPr>
+          <a:xfrm>
+            <a:off x="502920" y="128016"/>
+            <a:ext cx="11155680" cy="731520"/>
+          </a:xfrm>
+          <a:prstGeom prst="rect">
+            <a:avLst/>
+          </a:prstGeom>
+          <a:noFill/>
+        </p:spPr>
+        <p:txBody>
+          <a:bodyPr wrap="square">
+            <a:spAutoFit/>
+          </a:bodyPr>
+          <a:lstStyle/>
+          <a:p>
+            <a:pPr>
+              <a:spcAft>
+                <a:spcPts val="0"/>
+              </a:spcAft>
+            </a:pPr>
+            <a:r>
+              <a:rPr sz="3000" b="1">
+                <a:solidFill>
+                  <a:srgbClr val="FFFFFF"/>
+                </a:solidFill>
+                <a:latin typeface="Calibri"/>
+              </a:rPr>
+              <a:t>B4  Commercial-Filter Context</a:t>
+            </a:r>
+          </a:p>
+          <a:p>
+            <a:pPr>
+              <a:spcAft>
+                <a:spcPts val="0"/>
+              </a:spcAft>
+            </a:pPr>
+            <a:r>
+              <a:rPr sz="1300" b="0">
+                <a:solidFill>
+                  <a:srgbClr val="C7DAF2"/>
+                </a:solidFill>
+                <a:latin typeface="Calibri"/>
+              </a:rPr>
+              <a:t>Different test sets — not a head-to-head comparison</a:t>
+            </a:r>
+          </a:p>
+        </p:txBody>
+      </p:sp>
+      <p:graphicFrame>
+        <p:nvGraphicFramePr>
+          <p:cNvPr id="4" name="Table 3"/>
+          <p:cNvGraphicFramePr>
+            <a:graphicFrameLocks noGrp="1"/>
+          </p:cNvGraphicFramePr>
+          <p:nvPr/>
+        </p:nvGraphicFramePr>
+        <p:xfrm>
+          <a:off x="731520" y="1463040"/>
+          <a:ext cx="10698480" cy="1920240"/>
+        </p:xfrm>
+        <a:graphic>
+          <a:graphicData uri="http://schemas.openxmlformats.org/drawingml/2006/table">
+            <a:tbl>
+              <a:tblPr firstRow="1" bandRow="1">
+                <a:tableStyleId>{5C22544A-7EE6-4342-B048-85BDC9FD1C3A}</a:tableStyleId>
+              </a:tblPr>
+              <a:tblGrid>
+                <a:gridCol w="3017520"/>
+                <a:gridCol w="4023360"/>
+                <a:gridCol w="3657600"/>
+              </a:tblGrid>
+              <a:tr h="384048">
+                <a:tc>
+                  <a:txBody>
+                    <a:bodyPr/>
+                    <a:lstStyle/>
+                    <a:p>
+                      <a:pPr algn="l"/>
+                      <a:r>
+                        <a:rPr sz="1400" b="1">
+                          <a:solidFill>
+                            <a:srgbClr val="FFFFFF"/>
+                          </a:solidFill>
+                          <a:latin typeface="Calibri"/>
+                        </a:rPr>
+                        <a:t>System</a:t>
+                      </a:r>
+                    </a:p>
+                  </a:txBody>
+                  <a:tcPr/>
+                </a:tc>
+                <a:tc>
+                  <a:txBody>
+                    <a:bodyPr/>
+                    <a:lstStyle/>
+                    <a:p>
+                      <a:pPr algn="ctr"/>
+                      <a:r>
+                        <a:rPr sz="1400" b="1">
+                          <a:solidFill>
+                            <a:srgbClr val="FFFFFF"/>
+                          </a:solidFill>
+                          <a:latin typeface="Calibri"/>
+                        </a:rPr>
+                        <a:t>AI-phishing flagged</a:t>
+                      </a:r>
+                    </a:p>
+                  </a:txBody>
+                  <a:tcPr/>
+                </a:tc>
+                <a:tc>
+                  <a:txBody>
+                    <a:bodyPr/>
+                    <a:lstStyle/>
+                    <a:p>
+                      <a:pPr algn="ctr"/>
+                      <a:r>
+                        <a:rPr sz="1400" b="1">
+                          <a:solidFill>
+                            <a:srgbClr val="FFFFFF"/>
+                          </a:solidFill>
+                          <a:latin typeface="Calibri"/>
+                        </a:rPr>
+                        <a:t>Legitimate AI mail wrongly flagged</a:t>
+                      </a:r>
+                    </a:p>
+                  </a:txBody>
+                  <a:tcPr/>
+                </a:tc>
+              </a:tr>
+              <a:tr h="384048">
+                <a:tc>
+                  <a:txBody>
+                    <a:bodyPr/>
+                    <a:lstStyle/>
+                    <a:p>
+                      <a:pPr algn="l"/>
+                      <a:r>
+                        <a:rPr sz="1400" b="0">
+                          <a:solidFill>
+                            <a:srgbClr val="1F2A37"/>
+                          </a:solidFill>
+                          <a:latin typeface="Calibri"/>
+                        </a:rPr>
+                        <a:t>Gmail</a:t>
+                      </a:r>
+                    </a:p>
+                  </a:txBody>
+                  <a:tcPr/>
+                </a:tc>
+                <a:tc>
+                  <a:txBody>
+                    <a:bodyPr/>
+                    <a:lstStyle/>
+                    <a:p>
+                      <a:pPr algn="ctr"/>
+                      <a:r>
+                        <a:rPr sz="1400" b="0">
+                          <a:solidFill>
+                            <a:srgbClr val="1F2A37"/>
+                          </a:solidFill>
+                          <a:latin typeface="Calibri"/>
+                        </a:rPr>
+                        <a:t>≈ 14%  (n = 63, Opara et al.)</a:t>
+                      </a:r>
+                    </a:p>
+                  </a:txBody>
+                  <a:tcPr/>
+                </a:tc>
+                <a:tc>
+                  <a:txBody>
+                    <a:bodyPr/>
+                    <a:lstStyle/>
+                    <a:p>
+                      <a:pPr algn="ctr"/>
+                      <a:r>
+                        <a:rPr sz="1400" b="0">
+                          <a:solidFill>
+                            <a:srgbClr val="1F2A37"/>
+                          </a:solidFill>
+                          <a:latin typeface="Calibri"/>
+                        </a:rPr>
+                        <a:t>Low  (≈ 1.6%)</a:t>
+                      </a:r>
+                    </a:p>
+                  </a:txBody>
+                  <a:tcPr/>
+                </a:tc>
+              </a:tr>
+              <a:tr h="384048">
+                <a:tc>
+                  <a:txBody>
+                    <a:bodyPr/>
+                    <a:lstStyle/>
+                    <a:p>
+                      <a:pPr algn="l"/>
+                      <a:r>
+                        <a:rPr sz="1400" b="0">
+                          <a:solidFill>
+                            <a:srgbClr val="1F2A37"/>
+                          </a:solidFill>
+                          <a:latin typeface="Calibri"/>
+                        </a:rPr>
+                        <a:t>Outlook</a:t>
+                      </a:r>
+                    </a:p>
+                  </a:txBody>
+                  <a:tcPr/>
+                </a:tc>
+                <a:tc>
+                  <a:txBody>
+                    <a:bodyPr/>
+                    <a:lstStyle/>
+                    <a:p>
+                      <a:pPr algn="ctr"/>
+                      <a:r>
+                        <a:rPr sz="1400" b="0">
+                          <a:solidFill>
+                            <a:srgbClr val="1F2A37"/>
+                          </a:solidFill>
+                          <a:latin typeface="Calibri"/>
+                        </a:rPr>
+                        <a:t>≈ 4%  (n = 63)</a:t>
+                      </a:r>
+                    </a:p>
+                  </a:txBody>
+                  <a:tcPr/>
+                </a:tc>
+                <a:tc>
+                  <a:txBody>
+                    <a:bodyPr/>
+                    <a:lstStyle/>
+                    <a:p>
+                      <a:pPr algn="ctr"/>
+                      <a:r>
+                        <a:rPr sz="1400" b="0">
+                          <a:solidFill>
+                            <a:srgbClr val="1F2A37"/>
+                          </a:solidFill>
+                          <a:latin typeface="Calibri"/>
+                        </a:rPr>
+                        <a:t>≈ 0%</a:t>
+                      </a:r>
+                    </a:p>
+                  </a:txBody>
+                  <a:tcPr/>
+                </a:tc>
+              </a:tr>
+              <a:tr h="384048">
+                <a:tc>
+                  <a:txBody>
+                    <a:bodyPr/>
+                    <a:lstStyle/>
+                    <a:p>
+                      <a:pPr algn="l"/>
+                      <a:r>
+                        <a:rPr sz="1400" b="0">
+                          <a:solidFill>
+                            <a:srgbClr val="1F2A37"/>
+                          </a:solidFill>
+                          <a:latin typeface="Calibri"/>
+                        </a:rPr>
+                        <a:t>Yahoo</a:t>
+                      </a:r>
+                    </a:p>
+                  </a:txBody>
+                  <a:tcPr/>
+                </a:tc>
+                <a:tc>
+                  <a:txBody>
+                    <a:bodyPr/>
+                    <a:lstStyle/>
+                    <a:p>
+                      <a:pPr algn="ctr"/>
+                      <a:r>
+                        <a:rPr sz="1400" b="0">
+                          <a:solidFill>
+                            <a:srgbClr val="1F2A37"/>
+                          </a:solidFill>
+                          <a:latin typeface="Calibri"/>
+                        </a:rPr>
+                        <a:t>≈ 90%  (n = 63)</a:t>
+                      </a:r>
+                    </a:p>
+                  </a:txBody>
+                  <a:tcPr/>
+                </a:tc>
+                <a:tc>
+                  <a:txBody>
+                    <a:bodyPr/>
+                    <a:lstStyle/>
+                    <a:p>
+                      <a:pPr algn="ctr"/>
+                      <a:r>
+                        <a:rPr sz="1400" b="0">
+                          <a:solidFill>
+                            <a:srgbClr val="1F2A37"/>
+                          </a:solidFill>
+                          <a:latin typeface="Calibri"/>
+                        </a:rPr>
+                        <a:t>High  (≈ 59–67%)</a:t>
+                      </a:r>
+                    </a:p>
+                  </a:txBody>
+                  <a:tcPr/>
+                </a:tc>
+              </a:tr>
+              <a:tr h="384048">
+                <a:tc>
+                  <a:txBody>
+                    <a:bodyPr/>
+                    <a:lstStyle/>
+                    <a:p>
+                      <a:pPr algn="l"/>
+                      <a:r>
+                        <a:rPr sz="1400" b="0">
+                          <a:solidFill>
+                            <a:srgbClr val="1F2A37"/>
+                          </a:solidFill>
+                          <a:latin typeface="Calibri"/>
+                        </a:rPr>
+                        <a:t>This project</a:t>
+                      </a:r>
+                    </a:p>
+                  </a:txBody>
+                  <a:tcPr/>
+                </a:tc>
+                <a:tc>
+                  <a:txBody>
+                    <a:bodyPr/>
+                    <a:lstStyle/>
+                    <a:p>
+                      <a:pPr algn="ctr"/>
+                      <a:r>
+                        <a:rPr sz="1400" b="0">
+                          <a:solidFill>
+                            <a:srgbClr val="1F2A37"/>
+                          </a:solidFill>
+                          <a:latin typeface="Calibri"/>
+                        </a:rPr>
+                        <a:t>92%  (n = 4,986)</a:t>
+                      </a:r>
+                    </a:p>
+                  </a:txBody>
+                  <a:tcPr/>
+                </a:tc>
+                <a:tc>
+                  <a:txBody>
+                    <a:bodyPr/>
+                    <a:lstStyle/>
+                    <a:p>
+                      <a:pPr algn="ctr"/>
+                      <a:r>
+                        <a:rPr sz="1400" b="0">
+                          <a:solidFill>
+                            <a:srgbClr val="1F2A37"/>
+                          </a:solidFill>
+                          <a:latin typeface="Calibri"/>
+                        </a:rPr>
+                        <a:t>≈ 0.9% FPR on held-out corpus</a:t>
+                      </a:r>
+                    </a:p>
+                  </a:txBody>
+                  <a:tcPr/>
+                </a:tc>
+              </a:tr>
+            </a:tbl>
+          </a:graphicData>
+        </a:graphic>
+      </p:graphicFrame>
+      <p:sp>
+        <p:nvSpPr>
+          <p:cNvPr id="5" name="TextBox 4"/>
+          <p:cNvSpPr txBox="1"/>
+          <p:nvPr/>
+        </p:nvSpPr>
+        <p:spPr>
+          <a:xfrm>
+            <a:off x="822960" y="4023360"/>
+            <a:ext cx="10515600" cy="1828800"/>
+          </a:xfrm>
+          <a:prstGeom prst="rect">
+            <a:avLst/>
+          </a:prstGeom>
+          <a:noFill/>
+        </p:spPr>
+        <p:txBody>
+          <a:bodyPr wrap="square">
+            <a:spAutoFit/>
+          </a:bodyPr>
+          <a:lstStyle/>
+          <a:p>
+            <a:pPr>
+              <a:spcAft>
+                <a:spcPts val="1400"/>
+              </a:spcAft>
+            </a:pPr>
+            <a:r>
+              <a:rPr sz="1600">
+                <a:solidFill>
+                  <a:srgbClr val="1F2A37"/>
+                </a:solidFill>
+                <a:latin typeface="Calibri"/>
+              </a:rPr>
+              <a:t>•  No claim of superiority: different corpora, different sample sizes, different protocol</a:t>
+            </a:r>
+          </a:p>
+          <a:p>
+            <a:pPr>
+              <a:spcAft>
+                <a:spcPts val="1400"/>
+              </a:spcAft>
+            </a:pPr>
+            <a:r>
+              <a:rPr sz="1600">
+                <a:solidFill>
+                  <a:srgbClr val="1F2A37"/>
+                </a:solidFill>
+                <a:latin typeface="Calibri"/>
+              </a:rPr>
+              <a:t>•  A head-to-head test on one shared labelled corpus is Recommendation 2</a:t>
+            </a:r>
+          </a:p>
+        </p:txBody>
+      </p:sp>
+    </p:spTree>
+  </p:cSld>
+  <p:clrMapOvr>
+    <a:masterClrMapping/>
+  </p:clrMapOvr>
+</p:sld>
+</file>
+
+<file path=ppt/slides/slide19.xml><?xml version="1.0" encoding="utf-8"?>
+<p:sld xmlns:a="http://schemas.openxmlformats.org/drawingml/2006/main" xmlns:p="http://schemas.openxmlformats.org/presentationml/2006/main" xmlns:r="http://schemas.openxmlformats.org/officeDocument/2006/relationships">
+  <p:cSld>
+    <p:spTree>
+      <p:nvGrpSpPr>
+        <p:cNvPr id="1" name=""/>
+        <p:cNvGrpSpPr/>
+        <p:nvPr/>
+      </p:nvGrpSpPr>
+      <p:grpSpPr/>
+      <p:sp>
+        <p:nvSpPr>
+          <p:cNvPr id="2" name="Rectangle 1"/>
+          <p:cNvSpPr/>
+          <p:nvPr/>
+        </p:nvSpPr>
+        <p:spPr>
+          <a:xfrm>
+            <a:off x="0" y="0"/>
+            <a:ext cx="12191695" cy="960120"/>
+          </a:xfrm>
+          <a:prstGeom prst="rect">
+            <a:avLst/>
+          </a:prstGeom>
+          <a:solidFill>
+            <a:srgbClr val="0B2B5B"/>
+          </a:solidFill>
+          <a:ln>
+            <a:noFill/>
+          </a:ln>
+          <a:effectLst/>
+        </p:spPr>
+        <p:style>
+          <a:lnRef idx="1">
+            <a:schemeClr val="accent1"/>
+          </a:lnRef>
+          <a:fillRef idx="3">
+            <a:schemeClr val="accent1"/>
+          </a:fillRef>
+          <a:effectRef idx="2">
+            <a:schemeClr val="accent1"/>
+          </a:effectRef>
+          <a:fontRef idx="minor">
+            <a:schemeClr val="lt1"/>
+          </a:fontRef>
+        </p:style>
+        <p:txBody>
+          <a:bodyPr rtlCol="0" anchor="ctr"/>
+          <a:lstStyle/>
+          <a:p>
+            <a:pPr algn="ctr"/>
+          </a:p>
+        </p:txBody>
+      </p:sp>
+      <p:sp>
+        <p:nvSpPr>
+          <p:cNvPr id="3" name="TextBox 2"/>
+          <p:cNvSpPr txBox="1"/>
+          <p:nvPr/>
+        </p:nvSpPr>
+        <p:spPr>
+          <a:xfrm>
+            <a:off x="502920" y="128016"/>
+            <a:ext cx="11155680" cy="731520"/>
+          </a:xfrm>
+          <a:prstGeom prst="rect">
+            <a:avLst/>
+          </a:prstGeom>
+          <a:noFill/>
+        </p:spPr>
+        <p:txBody>
+          <a:bodyPr wrap="square">
+            <a:spAutoFit/>
+          </a:bodyPr>
+          <a:lstStyle/>
+          <a:p>
+            <a:pPr>
+              <a:spcAft>
+                <a:spcPts val="0"/>
+              </a:spcAft>
+            </a:pPr>
+            <a:r>
+              <a:rPr sz="3000" b="1">
+                <a:solidFill>
+                  <a:srgbClr val="FFFFFF"/>
+                </a:solidFill>
+                <a:latin typeface="Calibri"/>
+              </a:rPr>
+              <a:t>B5  Validation Gate — and Its Limit</a:t>
+            </a:r>
+          </a:p>
+        </p:txBody>
+      </p:sp>
+      <p:sp>
+        <p:nvSpPr>
+          <p:cNvPr id="4" name="TextBox 3"/>
+          <p:cNvSpPr txBox="1"/>
+          <p:nvPr/>
+        </p:nvSpPr>
+        <p:spPr>
+          <a:xfrm>
+            <a:off x="822960" y="1463040"/>
+            <a:ext cx="10515600" cy="2377440"/>
+          </a:xfrm>
+          <a:prstGeom prst="rect">
+            <a:avLst/>
+          </a:prstGeom>
+          <a:noFill/>
+        </p:spPr>
+        <p:txBody>
+          <a:bodyPr wrap="square">
+            <a:spAutoFit/>
+          </a:bodyPr>
+          <a:lstStyle/>
+          <a:p>
+            <a:pPr>
+              <a:spcAft>
+                <a:spcPts val="1400"/>
+              </a:spcAft>
+            </a:pPr>
+            <a:r>
+              <a:rPr sz="1700">
+                <a:solidFill>
+                  <a:srgbClr val="1F2A37"/>
+                </a:solidFill>
+                <a:latin typeface="Calibri"/>
+              </a:rPr>
+              <a:t>•  Retraining is reviewer-initiated; the system never retrains on its own</a:t>
+            </a:r>
+          </a:p>
+          <a:p>
+            <a:pPr>
+              <a:spcAft>
+                <a:spcPts val="1400"/>
+              </a:spcAft>
+            </a:pPr>
+            <a:r>
+              <a:rPr sz="1700">
+                <a:solidFill>
+                  <a:srgbClr val="1F2A37"/>
+                </a:solidFill>
+                <a:latin typeface="Calibri"/>
+              </a:rPr>
+              <a:t>•  A candidate is trained on the corpus plus accumulated corrections</a:t>
+            </a:r>
+          </a:p>
+          <a:p>
+            <a:pPr>
+              <a:spcAft>
+                <a:spcPts val="1400"/>
+              </a:spcAft>
+            </a:pPr>
+            <a:r>
+              <a:rPr sz="1700">
+                <a:solidFill>
+                  <a:srgbClr val="1F2A37"/>
+                </a:solidFill>
+                <a:latin typeface="Calibri"/>
+              </a:rPr>
+              <a:t>•  Both models are scored on the same held-out split (fixed seed)</a:t>
+            </a:r>
+          </a:p>
+          <a:p>
+            <a:pPr>
+              <a:spcAft>
+                <a:spcPts val="1400"/>
+              </a:spcAft>
+            </a:pPr>
+            <a:r>
+              <a:rPr sz="1700">
+                <a:solidFill>
+                  <a:srgbClr val="1F2A37"/>
+                </a:solidFill>
+                <a:latin typeface="Calibri"/>
+              </a:rPr>
+              <a:t>•  The candidate is deployed only if ranking quality is not reduced</a:t>
+            </a:r>
+          </a:p>
+          <a:p>
+            <a:pPr>
+              <a:spcAft>
+                <a:spcPts val="1400"/>
+              </a:spcAft>
+            </a:pPr>
+            <a:r>
+              <a:rPr sz="1700">
+                <a:solidFill>
+                  <a:srgbClr val="1F2A37"/>
+                </a:solidFill>
+                <a:latin typeface="Calibri"/>
+              </a:rPr>
+              <a:t>•  The replaced model is archived, so the previous version can be restored</a:t>
+            </a:r>
+          </a:p>
+        </p:txBody>
+      </p:sp>
+      <p:sp>
+        <p:nvSpPr>
+          <p:cNvPr id="5" name="Rounded Rectangle 4"/>
+          <p:cNvSpPr/>
+          <p:nvPr/>
+        </p:nvSpPr>
+        <p:spPr>
+          <a:xfrm>
+            <a:off x="822960" y="4114800"/>
+            <a:ext cx="10515600" cy="1828800"/>
+          </a:xfrm>
+          <a:prstGeom prst="roundRect">
+            <a:avLst>
+              <a:gd name="adj" fmla="val 6000"/>
+            </a:avLst>
+          </a:prstGeom>
+          <a:solidFill>
+            <a:srgbClr val="FFF7E6"/>
+          </a:solidFill>
+          <a:ln w="15875">
+            <a:solidFill>
+              <a:srgbClr val="E8C46A"/>
+            </a:solidFill>
+          </a:ln>
+          <a:effectLst/>
+        </p:spPr>
+        <p:style>
+          <a:lnRef idx="1">
+            <a:schemeClr val="accent1"/>
+          </a:lnRef>
+          <a:fillRef idx="3">
+            <a:schemeClr val="accent1"/>
+          </a:fillRef>
+          <a:effectRef idx="2">
+            <a:schemeClr val="accent1"/>
+          </a:effectRef>
+          <a:fontRef idx="minor">
+            <a:schemeClr val="lt1"/>
+          </a:fontRef>
+        </p:style>
+        <p:txBody>
+          <a:bodyPr rtlCol="0" anchor="ctr"/>
+          <a:lstStyle/>
+          <a:p>
+            <a:pPr algn="ctr"/>
+          </a:p>
+        </p:txBody>
+      </p:sp>
+      <p:sp>
+        <p:nvSpPr>
+          <p:cNvPr id="6" name="TextBox 5"/>
+          <p:cNvSpPr txBox="1"/>
+          <p:nvPr/>
+        </p:nvSpPr>
+        <p:spPr>
+          <a:xfrm>
+            <a:off x="1097280" y="4343400"/>
+            <a:ext cx="9966960" cy="1463040"/>
+          </a:xfrm>
+          <a:prstGeom prst="rect">
+            <a:avLst/>
+          </a:prstGeom>
+          <a:noFill/>
+        </p:spPr>
+        <p:txBody>
+          <a:bodyPr wrap="square">
+            <a:spAutoFit/>
+          </a:bodyPr>
+          <a:lstStyle/>
+          <a:p>
+            <a:pPr>
+              <a:spcAft>
+                <a:spcPts val="600"/>
+              </a:spcAft>
+            </a:pPr>
+            <a:r>
+              <a:rPr sz="1700" b="1">
+                <a:solidFill>
+                  <a:srgbClr val="0B2B5B"/>
+                </a:solidFill>
+                <a:latin typeface="Calibri"/>
+              </a:rPr>
+              <a:t>Known limit</a:t>
+            </a:r>
+          </a:p>
+          <a:p>
+            <a:pPr>
+              <a:spcAft>
+                <a:spcPts val="600"/>
+              </a:spcAft>
+            </a:pPr>
+            <a:r>
+              <a:rPr sz="1400" b="0">
+                <a:solidFill>
+                  <a:srgbClr val="1F2A37"/>
+                </a:solidFill>
+                <a:latin typeface="Calibri"/>
+              </a:rPr>
+              <a:t>The held-out split is drawn from the historical corpus, so corrections that are internally consistent but mislabelled are never tested against. The gate catches general degradation, not deliberate label poisoning — which is why the reviewer checkpoint and model archiving matter.</a:t>
+            </a:r>
+          </a:p>
+        </p:txBody>
+      </p:sp>
+    </p:spTree>
+  </p:cSld>
+  <p:clrMapOvr>
+    <a:masterClrMapping/>
+  </p:clrMapOvr>
+</p:sld>
+</file>
+
+<file path=ppt/slides/slide2.xml><?xml version="1.0" encoding="utf-8"?>
+<p:sld xmlns:a="http://schemas.openxmlformats.org/drawingml/2006/main" xmlns:p="http://schemas.openxmlformats.org/presentationml/2006/main" xmlns:r="http://schemas.openxmlformats.org/officeDocument/2006/relationships">
+  <p:cSld>
+    <p:spTree>
+      <p:nvGrpSpPr>
+        <p:cNvPr id="1" name=""/>
+        <p:cNvGrpSpPr/>
+        <p:nvPr/>
+      </p:nvGrpSpPr>
+      <p:grpSpPr/>
+      <p:sp>
+        <p:nvSpPr>
+          <p:cNvPr id="2" name="Rectangle 1"/>
+          <p:cNvSpPr/>
+          <p:nvPr/>
+        </p:nvSpPr>
+        <p:spPr>
+          <a:xfrm>
+            <a:off x="0" y="0"/>
+            <a:ext cx="12191695" cy="960120"/>
+          </a:xfrm>
+          <a:prstGeom prst="rect">
+            <a:avLst/>
+          </a:prstGeom>
+          <a:solidFill>
+            <a:srgbClr val="0B2B5B"/>
+          </a:solidFill>
+          <a:ln>
+            <a:noFill/>
+          </a:ln>
+          <a:effectLst/>
+        </p:spPr>
+        <p:style>
+          <a:lnRef idx="1">
+            <a:schemeClr val="accent1"/>
+          </a:lnRef>
+          <a:fillRef idx="3">
+            <a:schemeClr val="accent1"/>
+          </a:fillRef>
+          <a:effectRef idx="2">
+            <a:schemeClr val="accent1"/>
+          </a:effectRef>
+          <a:fontRef idx="minor">
+            <a:schemeClr val="lt1"/>
+          </a:fontRef>
+        </p:style>
+        <p:txBody>
+          <a:bodyPr rtlCol="0" anchor="ctr"/>
+          <a:lstStyle/>
+          <a:p>
+            <a:pPr algn="ctr"/>
+          </a:p>
+        </p:txBody>
+      </p:sp>
+      <p:sp>
+        <p:nvSpPr>
+          <p:cNvPr id="3" name="TextBox 2"/>
+          <p:cNvSpPr txBox="1"/>
+          <p:nvPr/>
+        </p:nvSpPr>
+        <p:spPr>
+          <a:xfrm>
+            <a:off x="502920" y="128016"/>
+            <a:ext cx="11155680" cy="731520"/>
+          </a:xfrm>
+          <a:prstGeom prst="rect">
+            <a:avLst/>
+          </a:prstGeom>
+          <a:noFill/>
+        </p:spPr>
+        <p:txBody>
+          <a:bodyPr wrap="square">
+            <a:spAutoFit/>
+          </a:bodyPr>
+          <a:lstStyle/>
+          <a:p>
+            <a:pPr>
+              <a:spcAft>
+                <a:spcPts val="0"/>
+              </a:spcAft>
+            </a:pPr>
+            <a:r>
+              <a:rPr sz="3000" b="1">
+                <a:solidFill>
+                  <a:srgbClr val="FFFFFF"/>
+                </a:solidFill>
+                <a:latin typeface="Calibri"/>
+              </a:rPr>
               <a:t>Outline</a:t>
             </a:r>
           </a:p>
@@ -7547,6 +10929,373 @@
           </a:p>
         </p:txBody>
       </p:sp>
+    </p:spTree>
+  </p:cSld>
+  <p:clrMapOvr>
+    <a:masterClrMapping/>
+  </p:clrMapOvr>
+</p:sld>
+</file>
+
+<file path=ppt/slides/slide20.xml><?xml version="1.0" encoding="utf-8"?>
+<p:sld xmlns:a="http://schemas.openxmlformats.org/drawingml/2006/main" xmlns:p="http://schemas.openxmlformats.org/presentationml/2006/main" xmlns:r="http://schemas.openxmlformats.org/officeDocument/2006/relationships">
+  <p:cSld>
+    <p:spTree>
+      <p:nvGrpSpPr>
+        <p:cNvPr id="1" name=""/>
+        <p:cNvGrpSpPr/>
+        <p:nvPr/>
+      </p:nvGrpSpPr>
+      <p:grpSpPr/>
+      <p:sp>
+        <p:nvSpPr>
+          <p:cNvPr id="2" name="Rectangle 1"/>
+          <p:cNvSpPr/>
+          <p:nvPr/>
+        </p:nvSpPr>
+        <p:spPr>
+          <a:xfrm>
+            <a:off x="0" y="0"/>
+            <a:ext cx="12191695" cy="960120"/>
+          </a:xfrm>
+          <a:prstGeom prst="rect">
+            <a:avLst/>
+          </a:prstGeom>
+          <a:solidFill>
+            <a:srgbClr val="0B2B5B"/>
+          </a:solidFill>
+          <a:ln>
+            <a:noFill/>
+          </a:ln>
+          <a:effectLst/>
+        </p:spPr>
+        <p:style>
+          <a:lnRef idx="1">
+            <a:schemeClr val="accent1"/>
+          </a:lnRef>
+          <a:fillRef idx="3">
+            <a:schemeClr val="accent1"/>
+          </a:fillRef>
+          <a:effectRef idx="2">
+            <a:schemeClr val="accent1"/>
+          </a:effectRef>
+          <a:fontRef idx="minor">
+            <a:schemeClr val="lt1"/>
+          </a:fontRef>
+        </p:style>
+        <p:txBody>
+          <a:bodyPr rtlCol="0" anchor="ctr"/>
+          <a:lstStyle/>
+          <a:p>
+            <a:pPr algn="ctr"/>
+          </a:p>
+        </p:txBody>
+      </p:sp>
+      <p:sp>
+        <p:nvSpPr>
+          <p:cNvPr id="3" name="TextBox 2"/>
+          <p:cNvSpPr txBox="1"/>
+          <p:nvPr/>
+        </p:nvSpPr>
+        <p:spPr>
+          <a:xfrm>
+            <a:off x="502920" y="128016"/>
+            <a:ext cx="11155680" cy="731520"/>
+          </a:xfrm>
+          <a:prstGeom prst="rect">
+            <a:avLst/>
+          </a:prstGeom>
+          <a:noFill/>
+        </p:spPr>
+        <p:txBody>
+          <a:bodyPr wrap="square">
+            <a:spAutoFit/>
+          </a:bodyPr>
+          <a:lstStyle/>
+          <a:p>
+            <a:pPr>
+              <a:spcAft>
+                <a:spcPts val="0"/>
+              </a:spcAft>
+            </a:pPr>
+            <a:r>
+              <a:rPr sz="3000" b="1">
+                <a:solidFill>
+                  <a:srgbClr val="FFFFFF"/>
+                </a:solidFill>
+                <a:latin typeface="Calibri"/>
+              </a:rPr>
+              <a:t>B6  Implementation Issues Encountered</a:t>
+            </a:r>
+          </a:p>
+        </p:txBody>
+      </p:sp>
+      <p:graphicFrame>
+        <p:nvGraphicFramePr>
+          <p:cNvPr id="4" name="Table 3"/>
+          <p:cNvGraphicFramePr>
+            <a:graphicFrameLocks noGrp="1"/>
+          </p:cNvGraphicFramePr>
+          <p:nvPr/>
+        </p:nvGraphicFramePr>
+        <p:xfrm>
+          <a:off x="822960" y="1417320"/>
+          <a:ext cx="10515600" cy="2304288"/>
+        </p:xfrm>
+        <a:graphic>
+          <a:graphicData uri="http://schemas.openxmlformats.org/drawingml/2006/table">
+            <a:tbl>
+              <a:tblPr firstRow="1" bandRow="1">
+                <a:tableStyleId>{5C22544A-7EE6-4342-B048-85BDC9FD1C3A}</a:tableStyleId>
+              </a:tblPr>
+              <a:tblGrid>
+                <a:gridCol w="5760720"/>
+                <a:gridCol w="4754880"/>
+              </a:tblGrid>
+              <a:tr h="384048">
+                <a:tc>
+                  <a:txBody>
+                    <a:bodyPr/>
+                    <a:lstStyle/>
+                    <a:p>
+                      <a:pPr algn="l"/>
+                      <a:r>
+                        <a:rPr sz="1400" b="1">
+                          <a:solidFill>
+                            <a:srgbClr val="FFFFFF"/>
+                          </a:solidFill>
+                          <a:latin typeface="Calibri"/>
+                        </a:rPr>
+                        <a:t>Issue</a:t>
+                      </a:r>
+                    </a:p>
+                  </a:txBody>
+                  <a:tcPr/>
+                </a:tc>
+                <a:tc>
+                  <a:txBody>
+                    <a:bodyPr/>
+                    <a:lstStyle/>
+                    <a:p>
+                      <a:pPr algn="ctr"/>
+                      <a:r>
+                        <a:rPr sz="1400" b="1">
+                          <a:solidFill>
+                            <a:srgbClr val="FFFFFF"/>
+                          </a:solidFill>
+                          <a:latin typeface="Calibri"/>
+                        </a:rPr>
+                        <a:t>Resolution</a:t>
+                      </a:r>
+                    </a:p>
+                  </a:txBody>
+                  <a:tcPr/>
+                </a:tc>
+              </a:tr>
+              <a:tr h="384048">
+                <a:tc>
+                  <a:txBody>
+                    <a:bodyPr/>
+                    <a:lstStyle/>
+                    <a:p>
+                      <a:pPr algn="l"/>
+                      <a:r>
+                        <a:rPr sz="1400" b="0">
+                          <a:solidFill>
+                            <a:srgbClr val="1F2A37"/>
+                          </a:solidFill>
+                          <a:latin typeface="Calibri"/>
+                        </a:rPr>
+                        <a:t>Email bodies exceeded Python's CSV field limit</a:t>
+                      </a:r>
+                    </a:p>
+                  </a:txBody>
+                  <a:tcPr/>
+                </a:tc>
+                <a:tc>
+                  <a:txBody>
+                    <a:bodyPr/>
+                    <a:lstStyle/>
+                    <a:p>
+                      <a:pPr algn="ctr"/>
+                      <a:r>
+                        <a:rPr sz="1400" b="0">
+                          <a:solidFill>
+                            <a:srgbClr val="1F2A37"/>
+                          </a:solidFill>
+                          <a:latin typeface="Calibri"/>
+                        </a:rPr>
+                        <a:t>Raised the limit on package import</a:t>
+                      </a:r>
+                    </a:p>
+                  </a:txBody>
+                  <a:tcPr/>
+                </a:tc>
+              </a:tr>
+              <a:tr h="384048">
+                <a:tc>
+                  <a:txBody>
+                    <a:bodyPr/>
+                    <a:lstStyle/>
+                    <a:p>
+                      <a:pPr algn="l"/>
+                      <a:r>
+                        <a:rPr sz="1400" b="0">
+                          <a:solidFill>
+                            <a:srgbClr val="1F2A37"/>
+                          </a:solidFill>
+                          <a:latin typeface="Calibri"/>
+                        </a:rPr>
+                        <a:t>Bracketed and IPv6-like URLs crashed the parser</a:t>
+                      </a:r>
+                    </a:p>
+                  </a:txBody>
+                  <a:tcPr/>
+                </a:tc>
+                <a:tc>
+                  <a:txBody>
+                    <a:bodyPr/>
+                    <a:lstStyle/>
+                    <a:p>
+                      <a:pPr algn="ctr"/>
+                      <a:r>
+                        <a:rPr sz="1400" b="0">
+                          <a:solidFill>
+                            <a:srgbClr val="1F2A37"/>
+                          </a:solidFill>
+                          <a:latin typeface="Calibri"/>
+                        </a:rPr>
+                        <a:t>Crash-safe URL extraction with fallback</a:t>
+                      </a:r>
+                    </a:p>
+                  </a:txBody>
+                  <a:tcPr/>
+                </a:tc>
+              </a:tr>
+              <a:tr h="384048">
+                <a:tc>
+                  <a:txBody>
+                    <a:bodyPr/>
+                    <a:lstStyle/>
+                    <a:p>
+                      <a:pPr algn="l"/>
+                      <a:r>
+                        <a:rPr sz="1400" b="0">
+                          <a:solidFill>
+                            <a:srgbClr val="1F2A37"/>
+                          </a:solidFill>
+                          <a:latin typeface="Calibri"/>
+                        </a:rPr>
+                        <a:t>Raw lengths dominated normalised TF-IDF values</a:t>
+                      </a:r>
+                    </a:p>
+                  </a:txBody>
+                  <a:tcPr/>
+                </a:tc>
+                <a:tc>
+                  <a:txBody>
+                    <a:bodyPr/>
+                    <a:lstStyle/>
+                    <a:p>
+                      <a:pPr algn="ctr"/>
+                      <a:r>
+                        <a:rPr sz="1400" b="0">
+                          <a:solidFill>
+                            <a:srgbClr val="1F2A37"/>
+                          </a:solidFill>
+                          <a:latin typeface="Calibri"/>
+                        </a:rPr>
+                        <a:t>Standardised metadata before fusion</a:t>
+                      </a:r>
+                    </a:p>
+                  </a:txBody>
+                  <a:tcPr/>
+                </a:tc>
+              </a:tr>
+              <a:tr h="384048">
+                <a:tc>
+                  <a:txBody>
+                    <a:bodyPr/>
+                    <a:lstStyle/>
+                    <a:p>
+                      <a:pPr algn="l"/>
+                      <a:r>
+                        <a:rPr sz="1400" b="0">
+                          <a:solidFill>
+                            <a:srgbClr val="1F2A37"/>
+                          </a:solidFill>
+                          <a:latin typeface="Calibri"/>
+                        </a:rPr>
+                        <a:t>One source file duplicated others</a:t>
+                      </a:r>
+                    </a:p>
+                  </a:txBody>
+                  <a:tcPr/>
+                </a:tc>
+                <a:tc>
+                  <a:txBody>
+                    <a:bodyPr/>
+                    <a:lstStyle/>
+                    <a:p>
+                      <a:pPr algn="ctr"/>
+                      <a:r>
+                        <a:rPr sz="1400" b="0">
+                          <a:solidFill>
+                            <a:srgbClr val="1F2A37"/>
+                          </a:solidFill>
+                          <a:latin typeface="Calibri"/>
+                        </a:rPr>
+                        <a:t>SHA-1 de-duplication: 82,500 → 81,152</a:t>
+                      </a:r>
+                    </a:p>
+                  </a:txBody>
+                  <a:tcPr/>
+                </a:tc>
+              </a:tr>
+              <a:tr h="384048">
+                <a:tc>
+                  <a:txBody>
+                    <a:bodyPr/>
+                    <a:lstStyle/>
+                    <a:p>
+                      <a:pPr algn="l"/>
+                      <a:r>
+                        <a:rPr sz="1400" b="0">
+                          <a:solidFill>
+                            <a:srgbClr val="1F2A37"/>
+                          </a:solidFill>
+                          <a:latin typeface="Calibri"/>
+                        </a:rPr>
+                        <a:t>Body-only external sets contain a single class</a:t>
+                      </a:r>
+                    </a:p>
+                  </a:txBody>
+                  <a:tcPr/>
+                </a:tc>
+                <a:tc>
+                  <a:txBody>
+                    <a:bodyPr/>
+                    <a:lstStyle/>
+                    <a:p>
+                      <a:pPr algn="ctr"/>
+                      <a:r>
+                        <a:rPr sz="1400" b="0">
+                          <a:solidFill>
+                            <a:srgbClr val="1F2A37"/>
+                          </a:solidFill>
+                          <a:latin typeface="Calibri"/>
+                        </a:rPr>
+                        <a:t>Report catch rate and threshold sweep instead</a:t>
+                      </a:r>
+                    </a:p>
+                  </a:txBody>
+                  <a:tcPr/>
+                </a:tc>
+              </a:tr>
+            </a:tbl>
+          </a:graphicData>
+        </a:graphic>
+      </p:graphicFrame>
     </p:spTree>
   </p:cSld>
   <p:clrMapOvr>
@@ -8776,7 +12525,7 @@
                 </a:solidFill>
                 <a:latin typeface="Calibri"/>
               </a:rPr>
-              <a:t>Hypotheses</a:t>
+              <a:t>Research Questions</a:t>
             </a:r>
           </a:p>
           <a:p>
@@ -8792,7 +12541,7 @@
                 </a:solidFill>
                 <a:latin typeface="Calibri"/>
               </a:rPr>
-              <a:t>Each is tested by a specific experiment in Chapter 6</a:t>
+              <a:t>Each is answered by a specific experiment in Chapter 6</a:t>
             </a:r>
           </a:p>
         </p:txBody>
@@ -8879,7 +12628,7 @@
                 </a:solidFill>
                 <a:latin typeface="Calibri"/>
               </a:rPr>
-              <a:t>H1  Combining textual content with structural metadata gives more robust detection than content alone.</a:t>
+              <a:t>Q1  Does combining textual content with structural metadata improve detection over content alone?</a:t>
             </a:r>
           </a:p>
           <a:p>
@@ -8895,7 +12644,7 @@
                 </a:solidFill>
                 <a:latin typeface="Calibri"/>
               </a:rPr>
-              <a:t>Tested by the content-only versus content–metadata comparison (Table 6.2).</a:t>
+              <a:t>Answered by the content-only versus content–metadata comparison (Table 6.2).</a:t>
             </a:r>
           </a:p>
         </p:txBody>
@@ -8982,7 +12731,7 @@
                 </a:solidFill>
                 <a:latin typeface="Calibri"/>
               </a:rPr>
-              <a:t>H2  Reviewed, validation-gated retraining improves detection of represented modern threats while maintaining main-corpus performance.</a:t>
+              <a:t>Q2  Can reviewed, validation-gated retraining improve detection of represented modern threats while maintaining main-corpus performance?</a:t>
             </a:r>
           </a:p>
           <a:p>
@@ -8998,7 +12747,7 @@
                 </a:solidFill>
                 <a:latin typeface="Calibri"/>
               </a:rPr>
-              <a:t>Tested by the before/after adaptive-retraining experiment (Table 6.4).</a:t>
+              <a:t>Answered by the before/after adaptive-retraining experiment (Table 6.4).</a:t>
             </a:r>
           </a:p>
         </p:txBody>

</xml_diff>